<commit_message>
[DELIVERABLES] Added presentation slides and sequence diagrams.
</commit_message>
<xml_diff>
--- a/ds-queuing-system/deliverables/slides/Presentazione Progetto.pptx
+++ b/ds-queuing-system/deliverables/slides/Presentazione Progetto.pptx
@@ -12,8 +12,9 @@
     <p:sldId id="258" r:id="rId6"/>
     <p:sldId id="263" r:id="rId7"/>
     <p:sldId id="259" r:id="rId8"/>
-    <p:sldId id="260" r:id="rId9"/>
-    <p:sldId id="264" r:id="rId10"/>
+    <p:sldId id="265" r:id="rId9"/>
+    <p:sldId id="260" r:id="rId10"/>
+    <p:sldId id="264" r:id="rId11"/>
   </p:sldIdLst>
   <p:sldSz cx="12192000" cy="6858000"/>
   <p:notesSz cx="6858000" cy="9144000"/>
@@ -112,6 +113,11 @@
       </a:defRPr>
     </a:lvl9pPr>
   </p:defaultTextStyle>
+  <p:extLst>
+    <p:ext uri="{EFAFB233-063F-42B5-8137-9DF3F51BA10A}">
+      <p15:sldGuideLst xmlns:p15="http://schemas.microsoft.com/office/powerpoint/2012/main"/>
+    </p:ext>
+  </p:extLst>
 </p:presentation>
 </file>
 
@@ -119,6 +125,7 @@
 <p1510:revInfo xmlns:a="http://schemas.openxmlformats.org/drawingml/2006/main" xmlns:r="http://schemas.openxmlformats.org/officeDocument/2006/relationships" xmlns:p1510="http://schemas.microsoft.com/office/powerpoint/2015/10/main">
   <p1510:revLst>
     <p1510:client id="{9E00D13F-E25D-493A-BE7F-9E3BC15CB715}" v="4" dt="2024-09-01T18:16:48.519"/>
+    <p1510:client id="{DC2CF1EE-756C-423F-B55B-7B3AE2B7E610}" v="1" dt="2024-09-02T07:48:12.260"/>
   </p1510:revLst>
 </p1510:revInfo>
 </file>
@@ -187,6 +194,76 @@
       </pc:sldChg>
     </pc:docChg>
   </pc:docChgLst>
+  <pc:docChgLst>
+    <pc:chgData name="Matteo Figini" userId="b11f85f5-4439-44ce-8347-b655c4eb67c2" providerId="ADAL" clId="{DC2CF1EE-756C-423F-B55B-7B3AE2B7E610}"/>
+    <pc:docChg chg="custSel addSld modSld">
+      <pc:chgData name="Matteo Figini" userId="b11f85f5-4439-44ce-8347-b655c4eb67c2" providerId="ADAL" clId="{DC2CF1EE-756C-423F-B55B-7B3AE2B7E610}" dt="2024-09-02T07:53:30.381" v="499" actId="20577"/>
+      <pc:docMkLst>
+        <pc:docMk/>
+      </pc:docMkLst>
+      <pc:sldChg chg="modSp mod">
+        <pc:chgData name="Matteo Figini" userId="b11f85f5-4439-44ce-8347-b655c4eb67c2" providerId="ADAL" clId="{DC2CF1EE-756C-423F-B55B-7B3AE2B7E610}" dt="2024-09-02T07:51:48.627" v="330" actId="20577"/>
+        <pc:sldMkLst>
+          <pc:docMk/>
+          <pc:sldMk cId="4156629879" sldId="259"/>
+        </pc:sldMkLst>
+        <pc:spChg chg="mod">
+          <ac:chgData name="Matteo Figini" userId="b11f85f5-4439-44ce-8347-b655c4eb67c2" providerId="ADAL" clId="{DC2CF1EE-756C-423F-B55B-7B3AE2B7E610}" dt="2024-09-02T07:51:48.627" v="330" actId="20577"/>
+          <ac:spMkLst>
+            <pc:docMk/>
+            <pc:sldMk cId="4156629879" sldId="259"/>
+            <ac:spMk id="3" creationId="{BE839F18-6640-632C-4C99-22B2A4BEA663}"/>
+          </ac:spMkLst>
+        </pc:spChg>
+      </pc:sldChg>
+      <pc:sldChg chg="addSp delSp modSp mod">
+        <pc:chgData name="Matteo Figini" userId="b11f85f5-4439-44ce-8347-b655c4eb67c2" providerId="ADAL" clId="{DC2CF1EE-756C-423F-B55B-7B3AE2B7E610}" dt="2024-09-02T07:48:16.817" v="5" actId="1076"/>
+        <pc:sldMkLst>
+          <pc:docMk/>
+          <pc:sldMk cId="4172879469" sldId="263"/>
+        </pc:sldMkLst>
+        <pc:spChg chg="del mod">
+          <ac:chgData name="Matteo Figini" userId="b11f85f5-4439-44ce-8347-b655c4eb67c2" providerId="ADAL" clId="{DC2CF1EE-756C-423F-B55B-7B3AE2B7E610}" dt="2024-09-02T07:48:12.260" v="1" actId="931"/>
+          <ac:spMkLst>
+            <pc:docMk/>
+            <pc:sldMk cId="4172879469" sldId="263"/>
+            <ac:spMk id="4" creationId="{5DF0977D-C95B-B580-720D-7DF932E314AD}"/>
+          </ac:spMkLst>
+        </pc:spChg>
+        <pc:picChg chg="add mod">
+          <ac:chgData name="Matteo Figini" userId="b11f85f5-4439-44ce-8347-b655c4eb67c2" providerId="ADAL" clId="{DC2CF1EE-756C-423F-B55B-7B3AE2B7E610}" dt="2024-09-02T07:48:16.817" v="5" actId="1076"/>
+          <ac:picMkLst>
+            <pc:docMk/>
+            <pc:sldMk cId="4172879469" sldId="263"/>
+            <ac:picMk id="6" creationId="{B3A92B76-4F6D-6D56-0085-86A406E797FB}"/>
+          </ac:picMkLst>
+        </pc:picChg>
+      </pc:sldChg>
+      <pc:sldChg chg="modSp new mod">
+        <pc:chgData name="Matteo Figini" userId="b11f85f5-4439-44ce-8347-b655c4eb67c2" providerId="ADAL" clId="{DC2CF1EE-756C-423F-B55B-7B3AE2B7E610}" dt="2024-09-02T07:53:30.381" v="499" actId="20577"/>
+        <pc:sldMkLst>
+          <pc:docMk/>
+          <pc:sldMk cId="1377587374" sldId="265"/>
+        </pc:sldMkLst>
+        <pc:spChg chg="mod">
+          <ac:chgData name="Matteo Figini" userId="b11f85f5-4439-44ce-8347-b655c4eb67c2" providerId="ADAL" clId="{DC2CF1EE-756C-423F-B55B-7B3AE2B7E610}" dt="2024-09-02T07:52:25.191" v="352" actId="20577"/>
+          <ac:spMkLst>
+            <pc:docMk/>
+            <pc:sldMk cId="1377587374" sldId="265"/>
+            <ac:spMk id="2" creationId="{A2C42C73-27A1-6C19-A4DF-E6C050EF7B05}"/>
+          </ac:spMkLst>
+        </pc:spChg>
+        <pc:spChg chg="mod">
+          <ac:chgData name="Matteo Figini" userId="b11f85f5-4439-44ce-8347-b655c4eb67c2" providerId="ADAL" clId="{DC2CF1EE-756C-423F-B55B-7B3AE2B7E610}" dt="2024-09-02T07:53:30.381" v="499" actId="20577"/>
+          <ac:spMkLst>
+            <pc:docMk/>
+            <pc:sldMk cId="1377587374" sldId="265"/>
+            <ac:spMk id="3" creationId="{7CAE885A-C0BC-F2A9-6F2B-12CF185EA1F3}"/>
+          </ac:spMkLst>
+        </pc:spChg>
+      </pc:sldChg>
+    </pc:docChg>
+  </pc:docChgLst>
 </pc:chgInfo>
 </file>
 
@@ -337,7 +414,7 @@
           <a:p>
             <a:fld id="{65E3D515-8563-4C3A-86A8-7F06002FBD9D}" type="datetimeFigureOut">
               <a:rPr lang="it-IT" smtClean="0"/>
-              <a:t>01/09/2024</a:t>
+              <a:t>02/09/2024</a:t>
             </a:fld>
             <a:endParaRPr lang="it-IT"/>
           </a:p>
@@ -535,7 +612,7 @@
           <a:p>
             <a:fld id="{65E3D515-8563-4C3A-86A8-7F06002FBD9D}" type="datetimeFigureOut">
               <a:rPr lang="it-IT" smtClean="0"/>
-              <a:t>01/09/2024</a:t>
+              <a:t>02/09/2024</a:t>
             </a:fld>
             <a:endParaRPr lang="it-IT"/>
           </a:p>
@@ -743,7 +820,7 @@
           <a:p>
             <a:fld id="{65E3D515-8563-4C3A-86A8-7F06002FBD9D}" type="datetimeFigureOut">
               <a:rPr lang="it-IT" smtClean="0"/>
-              <a:t>01/09/2024</a:t>
+              <a:t>02/09/2024</a:t>
             </a:fld>
             <a:endParaRPr lang="it-IT"/>
           </a:p>
@@ -941,7 +1018,7 @@
           <a:p>
             <a:fld id="{65E3D515-8563-4C3A-86A8-7F06002FBD9D}" type="datetimeFigureOut">
               <a:rPr lang="it-IT" smtClean="0"/>
-              <a:t>01/09/2024</a:t>
+              <a:t>02/09/2024</a:t>
             </a:fld>
             <a:endParaRPr lang="it-IT"/>
           </a:p>
@@ -1216,7 +1293,7 @@
           <a:p>
             <a:fld id="{65E3D515-8563-4C3A-86A8-7F06002FBD9D}" type="datetimeFigureOut">
               <a:rPr lang="it-IT" smtClean="0"/>
-              <a:t>01/09/2024</a:t>
+              <a:t>02/09/2024</a:t>
             </a:fld>
             <a:endParaRPr lang="it-IT"/>
           </a:p>
@@ -1481,7 +1558,7 @@
           <a:p>
             <a:fld id="{65E3D515-8563-4C3A-86A8-7F06002FBD9D}" type="datetimeFigureOut">
               <a:rPr lang="it-IT" smtClean="0"/>
-              <a:t>01/09/2024</a:t>
+              <a:t>02/09/2024</a:t>
             </a:fld>
             <a:endParaRPr lang="it-IT"/>
           </a:p>
@@ -1893,7 +1970,7 @@
           <a:p>
             <a:fld id="{65E3D515-8563-4C3A-86A8-7F06002FBD9D}" type="datetimeFigureOut">
               <a:rPr lang="it-IT" smtClean="0"/>
-              <a:t>01/09/2024</a:t>
+              <a:t>02/09/2024</a:t>
             </a:fld>
             <a:endParaRPr lang="it-IT"/>
           </a:p>
@@ -2034,7 +2111,7 @@
           <a:p>
             <a:fld id="{65E3D515-8563-4C3A-86A8-7F06002FBD9D}" type="datetimeFigureOut">
               <a:rPr lang="it-IT" smtClean="0"/>
-              <a:t>01/09/2024</a:t>
+              <a:t>02/09/2024</a:t>
             </a:fld>
             <a:endParaRPr lang="it-IT"/>
           </a:p>
@@ -2147,7 +2224,7 @@
           <a:p>
             <a:fld id="{65E3D515-8563-4C3A-86A8-7F06002FBD9D}" type="datetimeFigureOut">
               <a:rPr lang="it-IT" smtClean="0"/>
-              <a:t>01/09/2024</a:t>
+              <a:t>02/09/2024</a:t>
             </a:fld>
             <a:endParaRPr lang="it-IT"/>
           </a:p>
@@ -2458,7 +2535,7 @@
           <a:p>
             <a:fld id="{65E3D515-8563-4C3A-86A8-7F06002FBD9D}" type="datetimeFigureOut">
               <a:rPr lang="it-IT" smtClean="0"/>
-              <a:t>01/09/2024</a:t>
+              <a:t>02/09/2024</a:t>
             </a:fld>
             <a:endParaRPr lang="it-IT"/>
           </a:p>
@@ -2746,7 +2823,7 @@
           <a:p>
             <a:fld id="{65E3D515-8563-4C3A-86A8-7F06002FBD9D}" type="datetimeFigureOut">
               <a:rPr lang="it-IT" smtClean="0"/>
-              <a:t>01/09/2024</a:t>
+              <a:t>02/09/2024</a:t>
             </a:fld>
             <a:endParaRPr lang="it-IT"/>
           </a:p>
@@ -2987,7 +3064,7 @@
           <a:p>
             <a:fld id="{65E3D515-8563-4C3A-86A8-7F06002FBD9D}" type="datetimeFigureOut">
               <a:rPr lang="it-IT" smtClean="0"/>
-              <a:t>01/09/2024</a:t>
+              <a:t>02/09/2024</a:t>
             </a:fld>
             <a:endParaRPr lang="it-IT"/>
           </a:p>
@@ -3515,6 +3592,161 @@
 </p:sld>
 </file>
 
+<file path=ppt/slides/slide10.xml><?xml version="1.0" encoding="utf-8"?>
+<p:sld xmlns:a="http://schemas.openxmlformats.org/drawingml/2006/main" xmlns:r="http://schemas.openxmlformats.org/officeDocument/2006/relationships" xmlns:p="http://schemas.openxmlformats.org/presentationml/2006/main">
+  <p:cSld>
+    <p:spTree>
+      <p:nvGrpSpPr>
+        <p:cNvPr id="1" name=""/>
+        <p:cNvGrpSpPr/>
+        <p:nvPr/>
+      </p:nvGrpSpPr>
+      <p:grpSpPr>
+        <a:xfrm>
+          <a:off x="0" y="0"/>
+          <a:ext cx="0" cy="0"/>
+          <a:chOff x="0" y="0"/>
+          <a:chExt cx="0" cy="0"/>
+        </a:xfrm>
+      </p:grpSpPr>
+      <p:sp>
+        <p:nvSpPr>
+          <p:cNvPr id="2" name="Titolo 1">
+            <a:extLst>
+              <a:ext uri="{FF2B5EF4-FFF2-40B4-BE49-F238E27FC236}">
+                <a16:creationId xmlns:a16="http://schemas.microsoft.com/office/drawing/2014/main" id="{55044361-9314-E206-27F5-289DA3FA9B64}"/>
+              </a:ext>
+            </a:extLst>
+          </p:cNvPr>
+          <p:cNvSpPr>
+            <a:spLocks noGrp="1"/>
+          </p:cNvSpPr>
+          <p:nvPr>
+            <p:ph type="title"/>
+          </p:nvPr>
+        </p:nvSpPr>
+        <p:spPr/>
+        <p:txBody>
+          <a:bodyPr/>
+          <a:lstStyle/>
+          <a:p>
+            <a:r>
+              <a:rPr lang="it-IT" dirty="0" err="1"/>
+              <a:t>References</a:t>
+            </a:r>
+            <a:endParaRPr lang="it-IT" dirty="0"/>
+          </a:p>
+        </p:txBody>
+      </p:sp>
+      <p:sp>
+        <p:nvSpPr>
+          <p:cNvPr id="3" name="Segnaposto contenuto 2">
+            <a:extLst>
+              <a:ext uri="{FF2B5EF4-FFF2-40B4-BE49-F238E27FC236}">
+                <a16:creationId xmlns:a16="http://schemas.microsoft.com/office/drawing/2014/main" id="{CB2A3DC9-E5DA-5EC0-BAD1-763225B59A5A}"/>
+              </a:ext>
+            </a:extLst>
+          </p:cNvPr>
+          <p:cNvSpPr>
+            <a:spLocks noGrp="1"/>
+          </p:cNvSpPr>
+          <p:nvPr>
+            <p:ph idx="1"/>
+          </p:nvPr>
+        </p:nvSpPr>
+        <p:spPr/>
+        <p:txBody>
+          <a:bodyPr/>
+          <a:lstStyle/>
+          <a:p>
+            <a:r>
+              <a:rPr lang="en-US" dirty="0"/>
+              <a:t>D. </a:t>
+            </a:r>
+            <a:r>
+              <a:rPr lang="en-US" dirty="0" err="1"/>
+              <a:t>Ongaro</a:t>
+            </a:r>
+            <a:r>
+              <a:rPr lang="en-US" dirty="0"/>
+              <a:t>, J. </a:t>
+            </a:r>
+            <a:r>
+              <a:rPr lang="en-US" dirty="0" err="1"/>
+              <a:t>Ousterhout</a:t>
+            </a:r>
+            <a:r>
+              <a:rPr lang="en-US" dirty="0"/>
+              <a:t> </a:t>
+            </a:r>
+            <a:r>
+              <a:rPr lang="en-US" i="1" dirty="0"/>
+              <a:t>“In Search of an Understandable Consensus Algorithm”</a:t>
+            </a:r>
+            <a:r>
+              <a:rPr lang="en-US" dirty="0"/>
+              <a:t> USENIX Annual Technical Conference, 2014: </a:t>
+            </a:r>
+            <a:r>
+              <a:rPr lang="en-US" dirty="0">
+                <a:hlinkClick r:id="rId2"/>
+              </a:rPr>
+              <a:t>https://raft.github.io/</a:t>
+            </a:r>
+            <a:endParaRPr lang="it-IT" dirty="0"/>
+          </a:p>
+          <a:p>
+            <a:r>
+              <a:rPr lang="it-IT" dirty="0"/>
+              <a:t>Martin </a:t>
+            </a:r>
+            <a:r>
+              <a:rPr lang="it-IT" dirty="0" err="1"/>
+              <a:t>Kleppmann’s</a:t>
+            </a:r>
+            <a:r>
+              <a:rPr lang="it-IT" dirty="0"/>
+              <a:t> </a:t>
+            </a:r>
+            <a:r>
+              <a:rPr lang="it-IT" dirty="0" err="1"/>
+              <a:t>lecture</a:t>
+            </a:r>
+            <a:r>
+              <a:rPr lang="it-IT" dirty="0"/>
+              <a:t> on Raft </a:t>
+            </a:r>
+            <a:r>
+              <a:rPr lang="it-IT" dirty="0" err="1"/>
+              <a:t>protocol</a:t>
+            </a:r>
+            <a:r>
+              <a:rPr lang="it-IT" dirty="0"/>
+              <a:t>: </a:t>
+            </a:r>
+            <a:r>
+              <a:rPr lang="it-IT" dirty="0">
+                <a:hlinkClick r:id="rId3"/>
+              </a:rPr>
+              <a:t>https://www.youtube.com/watch?v=uXEYuDwm7e4</a:t>
+            </a:r>
+            <a:endParaRPr lang="it-IT" dirty="0"/>
+          </a:p>
+        </p:txBody>
+      </p:sp>
+    </p:spTree>
+    <p:extLst>
+      <p:ext uri="{BB962C8B-B14F-4D97-AF65-F5344CB8AC3E}">
+        <p14:creationId xmlns:p14="http://schemas.microsoft.com/office/powerpoint/2010/main" val="3690644163"/>
+      </p:ext>
+    </p:extLst>
+  </p:cSld>
+  <p:clrMapOvr>
+    <a:masterClrMapping/>
+  </p:clrMapOvr>
+</p:sld>
+</file>
+
 <file path=ppt/slides/slide2.xml><?xml version="1.0" encoding="utf-8"?>
 <p:sld xmlns:a="http://schemas.openxmlformats.org/drawingml/2006/main" xmlns:r="http://schemas.openxmlformats.org/officeDocument/2006/relationships" xmlns:p="http://schemas.openxmlformats.org/presentationml/2006/main">
   <p:cSld>
@@ -4757,52 +4989,41 @@
           </a:p>
         </p:txBody>
       </p:sp>
-      <p:sp>
-        <p:nvSpPr>
-          <p:cNvPr id="4" name="Segnaposto contenuto 3">
-            <a:extLst>
-              <a:ext uri="{FF2B5EF4-FFF2-40B4-BE49-F238E27FC236}">
-                <a16:creationId xmlns:a16="http://schemas.microsoft.com/office/drawing/2014/main" id="{5DF0977D-C95B-B580-720D-7DF932E314AD}"/>
-              </a:ext>
-            </a:extLst>
-          </p:cNvPr>
-          <p:cNvSpPr>
-            <a:spLocks noGrp="1"/>
-          </p:cNvSpPr>
+      <p:pic>
+        <p:nvPicPr>
+          <p:cNvPr id="6" name="Segnaposto contenuto 5" descr="Immagine che contiene testo, schermata, Carattere, numero&#10;&#10;Descrizione generata automaticamente">
+            <a:extLst>
+              <a:ext uri="{FF2B5EF4-FFF2-40B4-BE49-F238E27FC236}">
+                <a16:creationId xmlns:a16="http://schemas.microsoft.com/office/drawing/2014/main" id="{B3A92B76-4F6D-6D56-0085-86A406E797FB}"/>
+              </a:ext>
+            </a:extLst>
+          </p:cNvPr>
+          <p:cNvPicPr>
+            <a:picLocks noGrp="1" noChangeAspect="1"/>
+          </p:cNvPicPr>
           <p:nvPr>
             <p:ph sz="half" idx="2"/>
           </p:nvPr>
-        </p:nvSpPr>
-        <p:spPr/>
-        <p:txBody>
-          <a:bodyPr>
-            <a:normAutofit fontScale="92500" lnSpcReduction="10000"/>
-          </a:bodyPr>
-          <a:lstStyle/>
-          <a:p>
-            <a:r>
-              <a:rPr lang="it-IT" dirty="0"/>
-              <a:t>&lt;</a:t>
-            </a:r>
-            <a:r>
-              <a:rPr lang="it-IT" dirty="0" err="1"/>
-              <a:t>sequence</a:t>
-            </a:r>
-            <a:r>
-              <a:rPr lang="it-IT" dirty="0"/>
-              <a:t> </a:t>
-            </a:r>
-            <a:r>
-              <a:rPr lang="it-IT" dirty="0" err="1"/>
-              <a:t>diag</a:t>
-            </a:r>
-            <a:r>
-              <a:rPr lang="it-IT" dirty="0"/>
-              <a:t> inizializzazione client&gt;</a:t>
-            </a:r>
-          </a:p>
-        </p:txBody>
-      </p:sp>
+        </p:nvPicPr>
+        <p:blipFill>
+          <a:blip r:embed="rId2">
+            <a:extLst>
+              <a:ext uri="{28A0092B-C50C-407E-A947-70E740481C1C}">
+                <a14:useLocalDpi xmlns:a14="http://schemas.microsoft.com/office/drawing/2010/main" val="0"/>
+              </a:ext>
+            </a:extLst>
+          </a:blip>
+          <a:stretch>
+            <a:fillRect/>
+          </a:stretch>
+        </p:blipFill>
+        <p:spPr>
+          <a:xfrm>
+            <a:off x="5921547" y="1690688"/>
+            <a:ext cx="5599402" cy="4300340"/>
+          </a:xfrm>
+        </p:spPr>
+      </p:pic>
     </p:spTree>
     <p:extLst>
       <p:ext uri="{BB962C8B-B14F-4D97-AF65-F5344CB8AC3E}">
@@ -4888,7 +5109,7 @@
         <p:spPr/>
         <p:txBody>
           <a:bodyPr>
-            <a:normAutofit lnSpcReduction="10000"/>
+            <a:normAutofit/>
           </a:bodyPr>
           <a:lstStyle/>
           <a:p>
@@ -5016,111 +5237,116 @@
             </a:r>
             <a:r>
               <a:rPr lang="it-IT" dirty="0" err="1"/>
-              <a:t>particular</a:t>
-            </a:r>
-            <a:r>
-              <a:rPr lang="it-IT" dirty="0"/>
-              <a:t>:</a:t>
-            </a:r>
-          </a:p>
-          <a:p>
-            <a:pPr lvl="1"/>
-            <a:r>
-              <a:rPr lang="it-IT" dirty="0"/>
-              <a:t>&lt;scrivi modifiche&gt;</a:t>
-            </a:r>
-          </a:p>
-          <a:p>
-            <a:pPr lvl="1"/>
+              <a:t>detail</a:t>
+            </a:r>
+            <a:r>
+              <a:rPr lang="it-IT" dirty="0"/>
+              <a:t>, </a:t>
+            </a:r>
+            <a:r>
+              <a:rPr lang="it-IT" dirty="0" err="1"/>
+              <a:t>we</a:t>
+            </a:r>
+            <a:r>
+              <a:rPr lang="it-IT" dirty="0"/>
+              <a:t> </a:t>
+            </a:r>
+            <a:r>
+              <a:rPr lang="it-IT" dirty="0" err="1"/>
+              <a:t>removed</a:t>
+            </a:r>
+            <a:r>
+              <a:rPr lang="it-IT" dirty="0"/>
+              <a:t> the </a:t>
+            </a:r>
+            <a:r>
+              <a:rPr lang="it-IT" dirty="0" err="1"/>
+              <a:t>heartbeat</a:t>
+            </a:r>
+            <a:r>
+              <a:rPr lang="it-IT" dirty="0"/>
+              <a:t> </a:t>
+            </a:r>
+            <a:r>
+              <a:rPr lang="it-IT" dirty="0" err="1"/>
+              <a:t>among</a:t>
+            </a:r>
+            <a:r>
+              <a:rPr lang="it-IT" dirty="0"/>
+              <a:t> brokers in </a:t>
+            </a:r>
+            <a:r>
+              <a:rPr lang="it-IT" dirty="0" err="1"/>
+              <a:t>favour</a:t>
+            </a:r>
+            <a:r>
+              <a:rPr lang="it-IT" dirty="0"/>
+              <a:t> of </a:t>
+            </a:r>
+            <a:r>
+              <a:rPr lang="it-IT" dirty="0" err="1"/>
+              <a:t>directly</a:t>
+            </a:r>
+            <a:r>
+              <a:rPr lang="it-IT" dirty="0"/>
+              <a:t> </a:t>
+            </a:r>
+            <a:r>
+              <a:rPr lang="it-IT" dirty="0" err="1"/>
+              <a:t>listening</a:t>
+            </a:r>
+            <a:r>
+              <a:rPr lang="it-IT" dirty="0"/>
+              <a:t> on the </a:t>
+            </a:r>
+            <a:r>
+              <a:rPr lang="it-IT" dirty="0" err="1"/>
+              <a:t>socket</a:t>
+            </a:r>
+            <a:r>
+              <a:rPr lang="it-IT" dirty="0"/>
+              <a:t> </a:t>
+            </a:r>
+            <a:r>
+              <a:rPr lang="it-IT" dirty="0" err="1"/>
+              <a:t>disconnection</a:t>
+            </a:r>
+            <a:r>
+              <a:rPr lang="it-IT" dirty="0"/>
+              <a:t> events, to </a:t>
+            </a:r>
+            <a:r>
+              <a:rPr lang="it-IT" dirty="0" err="1"/>
+              <a:t>simplify</a:t>
+            </a:r>
+            <a:r>
+              <a:rPr lang="it-IT" dirty="0"/>
+              <a:t> the </a:t>
+            </a:r>
+            <a:r>
+              <a:rPr lang="it-IT" dirty="0" err="1"/>
+              <a:t>communication</a:t>
+            </a:r>
+            <a:r>
+              <a:rPr lang="it-IT" dirty="0"/>
+              <a:t> </a:t>
+            </a:r>
+            <a:r>
+              <a:rPr lang="it-IT" dirty="0" err="1"/>
+              <a:t>among</a:t>
+            </a:r>
+            <a:r>
+              <a:rPr lang="it-IT" dirty="0"/>
+              <a:t> the brokers and to reduce the </a:t>
+            </a:r>
+            <a:r>
+              <a:rPr lang="it-IT" dirty="0" err="1"/>
+              <a:t>traffic</a:t>
+            </a:r>
             <a:endParaRPr lang="it-IT" dirty="0"/>
           </a:p>
           <a:p>
-            <a:pPr lvl="1"/>
             <a:endParaRPr lang="it-IT" dirty="0"/>
-          </a:p>
-          <a:p>
-            <a:pPr marL="0" indent="0">
-              <a:buNone/>
-            </a:pPr>
-            <a:endParaRPr lang="it-IT" dirty="0"/>
-          </a:p>
-          <a:p>
-            <a:pPr marL="0" indent="0">
-              <a:buNone/>
-            </a:pPr>
-            <a:endParaRPr lang="it-IT" dirty="0"/>
-          </a:p>
-          <a:p>
-            <a:pPr marL="0" indent="0">
-              <a:buNone/>
-            </a:pPr>
-            <a:r>
-              <a:rPr lang="en-US" sz="1600" dirty="0">
-                <a:hlinkClick r:id="rId2"/>
-              </a:rPr>
-              <a:t>In Search of an Understandable Consensus Algorithm (Extended Version), D. </a:t>
-            </a:r>
-            <a:r>
-              <a:rPr lang="en-US" sz="1600" dirty="0" err="1">
-                <a:hlinkClick r:id="rId2"/>
-              </a:rPr>
-              <a:t>Ongaro</a:t>
-            </a:r>
-            <a:r>
-              <a:rPr lang="en-US" sz="1600" dirty="0">
-                <a:hlinkClick r:id="rId2"/>
-              </a:rPr>
-              <a:t> &amp; J. </a:t>
-            </a:r>
-            <a:r>
-              <a:rPr lang="en-US" sz="1600" dirty="0" err="1">
-                <a:hlinkClick r:id="rId2"/>
-              </a:rPr>
-              <a:t>Ousterhout</a:t>
-            </a:r>
-            <a:endParaRPr lang="en-US" sz="1600" dirty="0"/>
-          </a:p>
-          <a:p>
-            <a:pPr marL="0" indent="0">
-              <a:buNone/>
-            </a:pPr>
-            <a:r>
-              <a:rPr lang="it-IT" sz="1600" dirty="0">
-                <a:hlinkClick r:id="rId3"/>
-              </a:rPr>
-              <a:t>Martin </a:t>
-            </a:r>
-            <a:r>
-              <a:rPr lang="it-IT" sz="1600" dirty="0" err="1">
-                <a:hlinkClick r:id="rId3"/>
-              </a:rPr>
-              <a:t>Kleppmann’s</a:t>
-            </a:r>
-            <a:r>
-              <a:rPr lang="it-IT" sz="1600" dirty="0">
-                <a:hlinkClick r:id="rId3"/>
-              </a:rPr>
-              <a:t> </a:t>
-            </a:r>
-            <a:r>
-              <a:rPr lang="it-IT" sz="1600" dirty="0" err="1">
-                <a:hlinkClick r:id="rId3"/>
-              </a:rPr>
-              <a:t>lecture</a:t>
-            </a:r>
-            <a:r>
-              <a:rPr lang="it-IT" sz="1600" dirty="0">
-                <a:hlinkClick r:id="rId3"/>
-              </a:rPr>
-              <a:t> on Raft </a:t>
-            </a:r>
-            <a:r>
-              <a:rPr lang="it-IT" sz="1600" dirty="0" err="1">
-                <a:hlinkClick r:id="rId3"/>
-              </a:rPr>
-              <a:t>protocol</a:t>
-            </a:r>
-            <a:endParaRPr lang="it-IT" sz="1600" dirty="0"/>
           </a:p>
         </p:txBody>
       </p:sp>
@@ -5159,7 +5385,7 @@
           <p:cNvPr id="2" name="Titolo 1">
             <a:extLst>
               <a:ext uri="{FF2B5EF4-FFF2-40B4-BE49-F238E27FC236}">
-                <a16:creationId xmlns:a16="http://schemas.microsoft.com/office/drawing/2014/main" id="{6AF69ABD-2A74-2DA5-D849-181C722EBC3D}"/>
+                <a16:creationId xmlns:a16="http://schemas.microsoft.com/office/drawing/2014/main" id="{A2C42C73-27A1-6C19-A4DF-E6C050EF7B05}"/>
               </a:ext>
             </a:extLst>
           </p:cNvPr>
@@ -5177,7 +5403,7 @@
           <a:p>
             <a:r>
               <a:rPr lang="it-IT" dirty="0"/>
-              <a:t>How to play with the project</a:t>
+              <a:t>Application features	</a:t>
             </a:r>
           </a:p>
         </p:txBody>
@@ -5187,7 +5413,7 @@
           <p:cNvPr id="3" name="Segnaposto contenuto 2">
             <a:extLst>
               <a:ext uri="{FF2B5EF4-FFF2-40B4-BE49-F238E27FC236}">
-                <a16:creationId xmlns:a16="http://schemas.microsoft.com/office/drawing/2014/main" id="{8D6B3AFD-46E0-F20B-64A1-6946B52C0E55}"/>
+                <a16:creationId xmlns:a16="http://schemas.microsoft.com/office/drawing/2014/main" id="{7CAE885A-C0BC-F2A9-6F2B-12CF185EA1F3}"/>
               </a:ext>
             </a:extLst>
           </p:cNvPr>
@@ -5200,575 +5426,21 @@
         </p:nvSpPr>
         <p:spPr/>
         <p:txBody>
-          <a:bodyPr>
-            <a:normAutofit lnSpcReduction="10000"/>
-          </a:bodyPr>
-          <a:lstStyle/>
-          <a:p>
-            <a:r>
-              <a:rPr lang="it-IT" dirty="0">
-                <a:latin typeface="Cambria" panose="02040503050406030204" pitchFamily="18" charset="0"/>
-                <a:ea typeface="Cambria" panose="02040503050406030204" pitchFamily="18" charset="0"/>
-              </a:rPr>
-              <a:t>create &lt;</a:t>
-            </a:r>
-            <a:r>
-              <a:rPr lang="it-IT" dirty="0" err="1">
-                <a:latin typeface="Cambria" panose="02040503050406030204" pitchFamily="18" charset="0"/>
-                <a:ea typeface="Cambria" panose="02040503050406030204" pitchFamily="18" charset="0"/>
-              </a:rPr>
-              <a:t>queue_name</a:t>
-            </a:r>
-            <a:r>
-              <a:rPr lang="it-IT" dirty="0">
-                <a:latin typeface="Cambria" panose="02040503050406030204" pitchFamily="18" charset="0"/>
-                <a:ea typeface="Cambria" panose="02040503050406030204" pitchFamily="18" charset="0"/>
-              </a:rPr>
-              <a:t>&gt;</a:t>
-            </a:r>
-          </a:p>
-          <a:p>
-            <a:pPr lvl="1"/>
-            <a:r>
-              <a:rPr lang="it-IT" dirty="0" err="1"/>
-              <a:t>Creates</a:t>
-            </a:r>
-            <a:r>
-              <a:rPr lang="it-IT" dirty="0"/>
-              <a:t> a new </a:t>
-            </a:r>
-            <a:r>
-              <a:rPr lang="it-IT" dirty="0" err="1"/>
-              <a:t>queue</a:t>
-            </a:r>
-            <a:r>
-              <a:rPr lang="it-IT" dirty="0"/>
-              <a:t> with the name </a:t>
-            </a:r>
-            <a:r>
-              <a:rPr lang="it-IT" dirty="0" err="1"/>
-              <a:t>specified</a:t>
-            </a:r>
-            <a:r>
-              <a:rPr lang="it-IT" dirty="0"/>
-              <a:t> </a:t>
-            </a:r>
-            <a:r>
-              <a:rPr lang="it-IT" dirty="0" err="1"/>
-              <a:t>as</a:t>
-            </a:r>
-            <a:r>
-              <a:rPr lang="it-IT" dirty="0"/>
-              <a:t> </a:t>
-            </a:r>
-            <a:r>
-              <a:rPr lang="it-IT" dirty="0" err="1"/>
-              <a:t>parameter</a:t>
-            </a:r>
-            <a:r>
-              <a:rPr lang="it-IT" dirty="0"/>
-              <a:t> </a:t>
-            </a:r>
-            <a:r>
-              <a:rPr lang="it-IT" dirty="0" err="1">
-                <a:latin typeface="Cambria Math" panose="02040503050406030204" pitchFamily="18" charset="0"/>
-                <a:ea typeface="Cambria Math" panose="02040503050406030204" pitchFamily="18" charset="0"/>
-              </a:rPr>
-              <a:t>queue_name</a:t>
-            </a:r>
-            <a:r>
-              <a:rPr lang="it-IT" dirty="0"/>
-              <a:t>. In case the </a:t>
-            </a:r>
-            <a:r>
-              <a:rPr lang="it-IT" dirty="0" err="1"/>
-              <a:t>queue</a:t>
-            </a:r>
-            <a:r>
-              <a:rPr lang="it-IT" dirty="0"/>
-              <a:t> </a:t>
-            </a:r>
-            <a:r>
-              <a:rPr lang="it-IT" dirty="0" err="1"/>
-              <a:t>is</a:t>
-            </a:r>
-            <a:r>
-              <a:rPr lang="it-IT" dirty="0"/>
-              <a:t> </a:t>
-            </a:r>
-            <a:r>
-              <a:rPr lang="it-IT" dirty="0" err="1"/>
-              <a:t>already</a:t>
-            </a:r>
-            <a:r>
-              <a:rPr lang="it-IT" dirty="0"/>
-              <a:t> </a:t>
-            </a:r>
-            <a:r>
-              <a:rPr lang="it-IT" dirty="0" err="1"/>
-              <a:t>present</a:t>
-            </a:r>
-            <a:r>
-              <a:rPr lang="it-IT" dirty="0"/>
-              <a:t>, a warning </a:t>
-            </a:r>
-            <a:r>
-              <a:rPr lang="it-IT" dirty="0" err="1"/>
-              <a:t>is</a:t>
-            </a:r>
-            <a:r>
-              <a:rPr lang="it-IT" dirty="0"/>
-              <a:t> </a:t>
-            </a:r>
-            <a:r>
-              <a:rPr lang="it-IT" dirty="0" err="1"/>
-              <a:t>returned</a:t>
-            </a:r>
-            <a:r>
-              <a:rPr lang="it-IT" dirty="0"/>
-              <a:t> </a:t>
-            </a:r>
-            <a:r>
-              <a:rPr lang="it-IT" dirty="0" err="1"/>
-              <a:t>as</a:t>
-            </a:r>
-            <a:r>
-              <a:rPr lang="it-IT" dirty="0"/>
-              <a:t> </a:t>
-            </a:r>
-            <a:r>
-              <a:rPr lang="it-IT" dirty="0" err="1"/>
-              <a:t>response</a:t>
-            </a:r>
-            <a:r>
-              <a:rPr lang="it-IT" dirty="0"/>
-              <a:t>.</a:t>
-            </a:r>
-          </a:p>
-          <a:p>
-            <a:r>
-              <a:rPr lang="it-IT" dirty="0" err="1">
-                <a:latin typeface="Cambria Math" panose="02040503050406030204" pitchFamily="18" charset="0"/>
-                <a:ea typeface="Cambria Math" panose="02040503050406030204" pitchFamily="18" charset="0"/>
-              </a:rPr>
-              <a:t>append</a:t>
-            </a:r>
-            <a:r>
-              <a:rPr lang="it-IT" dirty="0">
-                <a:latin typeface="Cambria Math" panose="02040503050406030204" pitchFamily="18" charset="0"/>
-                <a:ea typeface="Cambria Math" panose="02040503050406030204" pitchFamily="18" charset="0"/>
-              </a:rPr>
-              <a:t> &lt;</a:t>
-            </a:r>
-            <a:r>
-              <a:rPr lang="it-IT" dirty="0" err="1">
-                <a:latin typeface="Cambria Math" panose="02040503050406030204" pitchFamily="18" charset="0"/>
-                <a:ea typeface="Cambria Math" panose="02040503050406030204" pitchFamily="18" charset="0"/>
-              </a:rPr>
-              <a:t>queue_name</a:t>
-            </a:r>
-            <a:r>
-              <a:rPr lang="it-IT" dirty="0">
-                <a:latin typeface="Cambria Math" panose="02040503050406030204" pitchFamily="18" charset="0"/>
-                <a:ea typeface="Cambria Math" panose="02040503050406030204" pitchFamily="18" charset="0"/>
-              </a:rPr>
-              <a:t>&gt; &lt;int_1&gt; &lt;int_2&gt; … &lt;</a:t>
-            </a:r>
-            <a:r>
-              <a:rPr lang="it-IT" dirty="0" err="1">
-                <a:latin typeface="Cambria Math" panose="02040503050406030204" pitchFamily="18" charset="0"/>
-                <a:ea typeface="Cambria Math" panose="02040503050406030204" pitchFamily="18" charset="0"/>
-              </a:rPr>
-              <a:t>int_n</a:t>
-            </a:r>
-            <a:r>
-              <a:rPr lang="it-IT" dirty="0">
-                <a:latin typeface="Cambria Math" panose="02040503050406030204" pitchFamily="18" charset="0"/>
-                <a:ea typeface="Cambria Math" panose="02040503050406030204" pitchFamily="18" charset="0"/>
-              </a:rPr>
-              <a:t>&gt;</a:t>
-            </a:r>
-          </a:p>
-          <a:p>
-            <a:pPr lvl="1"/>
-            <a:r>
-              <a:rPr lang="it-IT" dirty="0" err="1"/>
-              <a:t>Append</a:t>
-            </a:r>
-            <a:r>
-              <a:rPr lang="it-IT" dirty="0"/>
-              <a:t> to the </a:t>
-            </a:r>
-            <a:r>
-              <a:rPr lang="it-IT" dirty="0" err="1"/>
-              <a:t>queue</a:t>
-            </a:r>
-            <a:r>
-              <a:rPr lang="it-IT" dirty="0"/>
-              <a:t> </a:t>
-            </a:r>
-            <a:r>
-              <a:rPr lang="it-IT" dirty="0" err="1"/>
-              <a:t>specified</a:t>
-            </a:r>
-            <a:r>
-              <a:rPr lang="it-IT" dirty="0"/>
-              <a:t> </a:t>
-            </a:r>
-            <a:r>
-              <a:rPr lang="it-IT" dirty="0" err="1"/>
-              <a:t>as</a:t>
-            </a:r>
-            <a:r>
-              <a:rPr lang="it-IT" dirty="0"/>
-              <a:t> </a:t>
-            </a:r>
-            <a:r>
-              <a:rPr lang="it-IT" dirty="0" err="1"/>
-              <a:t>parameter</a:t>
-            </a:r>
-            <a:r>
-              <a:rPr lang="it-IT" dirty="0"/>
-              <a:t> </a:t>
-            </a:r>
-            <a:r>
-              <a:rPr lang="it-IT" dirty="0" err="1">
-                <a:latin typeface="Cambria Math" panose="02040503050406030204" pitchFamily="18" charset="0"/>
-                <a:ea typeface="Cambria Math" panose="02040503050406030204" pitchFamily="18" charset="0"/>
-              </a:rPr>
-              <a:t>queue_name</a:t>
-            </a:r>
-            <a:r>
-              <a:rPr lang="it-IT" dirty="0">
-                <a:latin typeface="Cambria Math" panose="02040503050406030204" pitchFamily="18" charset="0"/>
-                <a:ea typeface="Cambria Math" panose="02040503050406030204" pitchFamily="18" charset="0"/>
-              </a:rPr>
-              <a:t> </a:t>
-            </a:r>
-            <a:r>
-              <a:rPr lang="it-IT" dirty="0"/>
-              <a:t>the </a:t>
-            </a:r>
-            <a:r>
-              <a:rPr lang="it-IT" dirty="0" err="1"/>
-              <a:t>integer</a:t>
-            </a:r>
-            <a:r>
-              <a:rPr lang="it-IT" dirty="0"/>
-              <a:t> </a:t>
-            </a:r>
-            <a:r>
-              <a:rPr lang="it-IT" dirty="0" err="1"/>
-              <a:t>values</a:t>
-            </a:r>
-            <a:r>
-              <a:rPr lang="it-IT" dirty="0"/>
-              <a:t> </a:t>
-            </a:r>
-            <a:r>
-              <a:rPr lang="it-IT" dirty="0" err="1"/>
-              <a:t>specified</a:t>
-            </a:r>
-            <a:r>
-              <a:rPr lang="it-IT" dirty="0"/>
-              <a:t> </a:t>
-            </a:r>
-            <a:r>
-              <a:rPr lang="it-IT" dirty="0" err="1"/>
-              <a:t>afterwards</a:t>
-            </a:r>
-            <a:r>
-              <a:rPr lang="it-IT" dirty="0"/>
-              <a:t>, </a:t>
-            </a:r>
-            <a:r>
-              <a:rPr lang="it-IT" dirty="0" err="1"/>
-              <a:t>separated</a:t>
-            </a:r>
-            <a:r>
-              <a:rPr lang="it-IT" dirty="0"/>
-              <a:t> by a </a:t>
-            </a:r>
-            <a:r>
-              <a:rPr lang="it-IT" dirty="0" err="1"/>
-              <a:t>space</a:t>
-            </a:r>
-            <a:r>
-              <a:rPr lang="it-IT" dirty="0"/>
-              <a:t>. </a:t>
-            </a:r>
-          </a:p>
-          <a:p>
-            <a:pPr lvl="1"/>
-            <a:r>
-              <a:rPr lang="it-IT" dirty="0"/>
-              <a:t>A warning </a:t>
-            </a:r>
-            <a:r>
-              <a:rPr lang="it-IT" dirty="0" err="1"/>
-              <a:t>is</a:t>
-            </a:r>
-            <a:r>
-              <a:rPr lang="it-IT" dirty="0"/>
-              <a:t> </a:t>
-            </a:r>
-            <a:r>
-              <a:rPr lang="it-IT" dirty="0" err="1"/>
-              <a:t>returned</a:t>
-            </a:r>
-            <a:r>
-              <a:rPr lang="it-IT" dirty="0"/>
-              <a:t> in case the </a:t>
-            </a:r>
-            <a:r>
-              <a:rPr lang="it-IT" dirty="0" err="1"/>
-              <a:t>queue</a:t>
-            </a:r>
-            <a:r>
-              <a:rPr lang="it-IT" dirty="0"/>
-              <a:t> </a:t>
-            </a:r>
-            <a:r>
-              <a:rPr lang="it-IT" dirty="0" err="1"/>
-              <a:t>is</a:t>
-            </a:r>
-            <a:r>
-              <a:rPr lang="it-IT" dirty="0"/>
-              <a:t> </a:t>
-            </a:r>
-            <a:r>
-              <a:rPr lang="it-IT" dirty="0" err="1"/>
-              <a:t>unknown</a:t>
-            </a:r>
-            <a:r>
-              <a:rPr lang="it-IT" dirty="0"/>
-              <a:t>.</a:t>
-            </a:r>
-          </a:p>
-          <a:p>
-            <a:r>
-              <a:rPr lang="it-IT" dirty="0" err="1">
-                <a:latin typeface="Cambria Math" panose="02040503050406030204" pitchFamily="18" charset="0"/>
-                <a:ea typeface="Cambria Math" panose="02040503050406030204" pitchFamily="18" charset="0"/>
-              </a:rPr>
-              <a:t>read</a:t>
-            </a:r>
-            <a:r>
-              <a:rPr lang="it-IT" dirty="0">
-                <a:latin typeface="Cambria Math" panose="02040503050406030204" pitchFamily="18" charset="0"/>
-                <a:ea typeface="Cambria Math" panose="02040503050406030204" pitchFamily="18" charset="0"/>
-              </a:rPr>
-              <a:t> &lt;</a:t>
-            </a:r>
-            <a:r>
-              <a:rPr lang="it-IT" dirty="0" err="1">
-                <a:latin typeface="Cambria Math" panose="02040503050406030204" pitchFamily="18" charset="0"/>
-                <a:ea typeface="Cambria Math" panose="02040503050406030204" pitchFamily="18" charset="0"/>
-              </a:rPr>
-              <a:t>queue_name</a:t>
-            </a:r>
-            <a:r>
-              <a:rPr lang="it-IT" dirty="0">
-                <a:latin typeface="Cambria Math" panose="02040503050406030204" pitchFamily="18" charset="0"/>
-                <a:ea typeface="Cambria Math" panose="02040503050406030204" pitchFamily="18" charset="0"/>
-              </a:rPr>
-              <a:t>&gt;</a:t>
-            </a:r>
-          </a:p>
-          <a:p>
-            <a:pPr lvl="1"/>
-            <a:r>
-              <a:rPr lang="it-IT" dirty="0"/>
-              <a:t>Read </a:t>
-            </a:r>
-            <a:r>
-              <a:rPr lang="it-IT" dirty="0" err="1"/>
-              <a:t>all</a:t>
-            </a:r>
-            <a:r>
-              <a:rPr lang="it-IT" dirty="0"/>
-              <a:t> the </a:t>
-            </a:r>
-            <a:r>
-              <a:rPr lang="it-IT" dirty="0" err="1"/>
-              <a:t>values</a:t>
-            </a:r>
-            <a:r>
-              <a:rPr lang="it-IT" dirty="0"/>
-              <a:t> from the </a:t>
-            </a:r>
-            <a:r>
-              <a:rPr lang="it-IT" dirty="0" err="1"/>
-              <a:t>queue</a:t>
-            </a:r>
-            <a:r>
-              <a:rPr lang="it-IT" dirty="0"/>
-              <a:t> </a:t>
-            </a:r>
-            <a:r>
-              <a:rPr lang="it-IT" dirty="0" err="1"/>
-              <a:t>specified</a:t>
-            </a:r>
-            <a:r>
-              <a:rPr lang="it-IT" dirty="0"/>
-              <a:t> </a:t>
-            </a:r>
-            <a:r>
-              <a:rPr lang="it-IT" dirty="0" err="1"/>
-              <a:t>as</a:t>
-            </a:r>
-            <a:r>
-              <a:rPr lang="it-IT" dirty="0"/>
-              <a:t> </a:t>
-            </a:r>
-            <a:r>
-              <a:rPr lang="it-IT" dirty="0" err="1"/>
-              <a:t>parameter</a:t>
-            </a:r>
-            <a:r>
-              <a:rPr lang="it-IT" dirty="0"/>
-              <a:t> </a:t>
-            </a:r>
-            <a:r>
-              <a:rPr lang="it-IT" dirty="0" err="1">
-                <a:latin typeface="Cambria Math" panose="02040503050406030204" pitchFamily="18" charset="0"/>
-                <a:ea typeface="Cambria Math" panose="02040503050406030204" pitchFamily="18" charset="0"/>
-              </a:rPr>
-              <a:t>queue_name</a:t>
-            </a:r>
-            <a:r>
-              <a:rPr lang="it-IT" dirty="0">
-                <a:latin typeface="Cambria Math" panose="02040503050406030204" pitchFamily="18" charset="0"/>
-                <a:ea typeface="Cambria Math" panose="02040503050406030204" pitchFamily="18" charset="0"/>
-              </a:rPr>
-              <a:t> </a:t>
-            </a:r>
-            <a:r>
-              <a:rPr lang="it-IT" dirty="0" err="1"/>
-              <a:t>that</a:t>
-            </a:r>
-            <a:r>
-              <a:rPr lang="it-IT" dirty="0"/>
-              <a:t> are </a:t>
-            </a:r>
-            <a:r>
-              <a:rPr lang="it-IT" dirty="0" err="1"/>
-              <a:t>not</a:t>
-            </a:r>
-            <a:r>
-              <a:rPr lang="it-IT" dirty="0"/>
-              <a:t> </a:t>
-            </a:r>
-            <a:r>
-              <a:rPr lang="it-IT" dirty="0" err="1"/>
-              <a:t>yet</a:t>
-            </a:r>
-            <a:r>
-              <a:rPr lang="it-IT" dirty="0"/>
-              <a:t> </a:t>
-            </a:r>
-            <a:r>
-              <a:rPr lang="it-IT" dirty="0" err="1"/>
-              <a:t>read</a:t>
-            </a:r>
-            <a:r>
-              <a:rPr lang="it-IT" dirty="0"/>
-              <a:t> by the client.</a:t>
-            </a:r>
-          </a:p>
-          <a:p>
-            <a:pPr lvl="1"/>
-            <a:r>
-              <a:rPr lang="it-IT" dirty="0"/>
-              <a:t>A warning </a:t>
-            </a:r>
-            <a:r>
-              <a:rPr lang="it-IT" dirty="0" err="1"/>
-              <a:t>is</a:t>
-            </a:r>
-            <a:r>
-              <a:rPr lang="it-IT" dirty="0"/>
-              <a:t> </a:t>
-            </a:r>
-            <a:r>
-              <a:rPr lang="it-IT" dirty="0" err="1"/>
-              <a:t>returned</a:t>
-            </a:r>
-            <a:r>
-              <a:rPr lang="it-IT" dirty="0"/>
-              <a:t> in case the </a:t>
-            </a:r>
-            <a:r>
-              <a:rPr lang="it-IT" dirty="0" err="1"/>
-              <a:t>queue</a:t>
-            </a:r>
-            <a:r>
-              <a:rPr lang="it-IT" dirty="0"/>
-              <a:t> </a:t>
-            </a:r>
-            <a:r>
-              <a:rPr lang="it-IT" dirty="0" err="1"/>
-              <a:t>is</a:t>
-            </a:r>
-            <a:r>
-              <a:rPr lang="it-IT" dirty="0"/>
-              <a:t> </a:t>
-            </a:r>
-            <a:r>
-              <a:rPr lang="it-IT" dirty="0" err="1"/>
-              <a:t>unknown</a:t>
-            </a:r>
-            <a:r>
-              <a:rPr lang="it-IT" dirty="0"/>
-              <a:t> or </a:t>
-            </a:r>
-            <a:r>
-              <a:rPr lang="it-IT" dirty="0" err="1"/>
-              <a:t>if</a:t>
-            </a:r>
-            <a:r>
-              <a:rPr lang="it-IT" dirty="0"/>
-              <a:t> no new </a:t>
-            </a:r>
-            <a:r>
-              <a:rPr lang="it-IT" dirty="0" err="1"/>
-              <a:t>elements</a:t>
-            </a:r>
-            <a:r>
-              <a:rPr lang="it-IT" dirty="0"/>
-              <a:t> from the </a:t>
-            </a:r>
-            <a:r>
-              <a:rPr lang="it-IT" dirty="0" err="1"/>
-              <a:t>queue</a:t>
-            </a:r>
-            <a:r>
-              <a:rPr lang="it-IT" dirty="0"/>
-              <a:t> </a:t>
-            </a:r>
-            <a:r>
-              <a:rPr lang="it-IT" dirty="0" err="1"/>
-              <a:t>need</a:t>
-            </a:r>
-            <a:r>
-              <a:rPr lang="it-IT" dirty="0"/>
-              <a:t> to be </a:t>
-            </a:r>
-            <a:r>
-              <a:rPr lang="it-IT" dirty="0" err="1"/>
-              <a:t>read</a:t>
-            </a:r>
-            <a:r>
-              <a:rPr lang="it-IT" dirty="0"/>
-              <a:t>.</a:t>
-            </a:r>
+          <a:bodyPr/>
+          <a:lstStyle/>
+          <a:p>
+            <a:r>
+              <a:rPr lang="it-IT"/>
+              <a:t>&lt;completare&gt; </a:t>
+            </a:r>
+            <a:endParaRPr lang="it-IT" dirty="0"/>
           </a:p>
         </p:txBody>
       </p:sp>
     </p:spTree>
     <p:extLst>
       <p:ext uri="{BB962C8B-B14F-4D97-AF65-F5344CB8AC3E}">
-        <p14:creationId xmlns:p14="http://schemas.microsoft.com/office/powerpoint/2010/main" val="2982348974"/>
+        <p14:creationId xmlns:p14="http://schemas.microsoft.com/office/powerpoint/2010/main" val="1377587374"/>
       </p:ext>
     </p:extLst>
   </p:cSld>
@@ -5800,7 +5472,7 @@
           <p:cNvPr id="2" name="Titolo 1">
             <a:extLst>
               <a:ext uri="{FF2B5EF4-FFF2-40B4-BE49-F238E27FC236}">
-                <a16:creationId xmlns:a16="http://schemas.microsoft.com/office/drawing/2014/main" id="{55044361-9314-E206-27F5-289DA3FA9B64}"/>
+                <a16:creationId xmlns:a16="http://schemas.microsoft.com/office/drawing/2014/main" id="{6AF69ABD-2A74-2DA5-D849-181C722EBC3D}"/>
               </a:ext>
             </a:extLst>
           </p:cNvPr>
@@ -5817,10 +5489,9 @@
           <a:lstStyle/>
           <a:p>
             <a:r>
-              <a:rPr lang="it-IT" dirty="0" err="1"/>
-              <a:t>References</a:t>
-            </a:r>
-            <a:endParaRPr lang="it-IT" dirty="0"/>
+              <a:rPr lang="it-IT" dirty="0"/>
+              <a:t>How to play with the project</a:t>
+            </a:r>
           </a:p>
         </p:txBody>
       </p:sp>
@@ -5829,7 +5500,7 @@
           <p:cNvPr id="3" name="Segnaposto contenuto 2">
             <a:extLst>
               <a:ext uri="{FF2B5EF4-FFF2-40B4-BE49-F238E27FC236}">
-                <a16:creationId xmlns:a16="http://schemas.microsoft.com/office/drawing/2014/main" id="{CB2A3DC9-E5DA-5EC0-BAD1-763225B59A5A}"/>
+                <a16:creationId xmlns:a16="http://schemas.microsoft.com/office/drawing/2014/main" id="{8D6B3AFD-46E0-F20B-64A1-6946B52C0E55}"/>
               </a:ext>
             </a:extLst>
           </p:cNvPr>
@@ -5842,88 +5513,575 @@
         </p:nvSpPr>
         <p:spPr/>
         <p:txBody>
-          <a:bodyPr/>
-          <a:lstStyle/>
-          <a:p>
-            <a:r>
-              <a:rPr lang="en-US" dirty="0"/>
-              <a:t>D. </a:t>
-            </a:r>
-            <a:r>
-              <a:rPr lang="en-US" dirty="0" err="1"/>
-              <a:t>Ongaro</a:t>
-            </a:r>
-            <a:r>
-              <a:rPr lang="en-US" dirty="0"/>
-              <a:t>, J. </a:t>
-            </a:r>
-            <a:r>
-              <a:rPr lang="en-US" dirty="0" err="1"/>
-              <a:t>Ousterhout</a:t>
-            </a:r>
-            <a:r>
-              <a:rPr lang="en-US" dirty="0"/>
-              <a:t> </a:t>
-            </a:r>
-            <a:r>
-              <a:rPr lang="en-US" i="1" dirty="0"/>
-              <a:t>“In Search of an Understandable Consensus Algorithm”</a:t>
-            </a:r>
-            <a:r>
-              <a:rPr lang="en-US" dirty="0"/>
-              <a:t> USENIX Annual Technical Conference, 2014: </a:t>
-            </a:r>
-            <a:r>
-              <a:rPr lang="en-US" dirty="0">
-                <a:hlinkClick r:id="rId2"/>
+          <a:bodyPr>
+            <a:normAutofit lnSpcReduction="10000"/>
+          </a:bodyPr>
+          <a:lstStyle/>
+          <a:p>
+            <a:r>
+              <a:rPr lang="it-IT" dirty="0">
+                <a:latin typeface="Cambria" panose="02040503050406030204" pitchFamily="18" charset="0"/>
+                <a:ea typeface="Cambria" panose="02040503050406030204" pitchFamily="18" charset="0"/>
               </a:rPr>
-              <a:t>https://raft.github.io/</a:t>
-            </a:r>
-            <a:endParaRPr lang="it-IT" dirty="0"/>
-          </a:p>
-          <a:p>
-            <a:r>
-              <a:rPr lang="it-IT" dirty="0"/>
-              <a:t>Martin </a:t>
-            </a:r>
-            <a:r>
-              <a:rPr lang="it-IT" dirty="0" err="1"/>
-              <a:t>Kleppmann’s</a:t>
-            </a:r>
-            <a:r>
-              <a:rPr lang="it-IT" dirty="0"/>
-              <a:t> </a:t>
-            </a:r>
-            <a:r>
-              <a:rPr lang="it-IT" dirty="0" err="1"/>
-              <a:t>lecture</a:t>
-            </a:r>
-            <a:r>
-              <a:rPr lang="it-IT" dirty="0"/>
-              <a:t> on Raft </a:t>
-            </a:r>
-            <a:r>
-              <a:rPr lang="it-IT" dirty="0" err="1"/>
-              <a:t>protocol</a:t>
-            </a:r>
-            <a:r>
-              <a:rPr lang="it-IT" dirty="0"/>
-              <a:t>: </a:t>
+              <a:t>create &lt;</a:t>
+            </a:r>
+            <a:r>
+              <a:rPr lang="it-IT" dirty="0" err="1">
+                <a:latin typeface="Cambria" panose="02040503050406030204" pitchFamily="18" charset="0"/>
+                <a:ea typeface="Cambria" panose="02040503050406030204" pitchFamily="18" charset="0"/>
+              </a:rPr>
+              <a:t>queue_name</a:t>
             </a:r>
             <a:r>
               <a:rPr lang="it-IT" dirty="0">
-                <a:hlinkClick r:id="rId3"/>
+                <a:latin typeface="Cambria" panose="02040503050406030204" pitchFamily="18" charset="0"/>
+                <a:ea typeface="Cambria" panose="02040503050406030204" pitchFamily="18" charset="0"/>
               </a:rPr>
-              <a:t>https://www.youtube.com/watch?v=uXEYuDwm7e4</a:t>
-            </a:r>
-            <a:endParaRPr lang="it-IT" dirty="0"/>
+              <a:t>&gt;</a:t>
+            </a:r>
+          </a:p>
+          <a:p>
+            <a:pPr lvl="1"/>
+            <a:r>
+              <a:rPr lang="it-IT" dirty="0" err="1"/>
+              <a:t>Creates</a:t>
+            </a:r>
+            <a:r>
+              <a:rPr lang="it-IT" dirty="0"/>
+              <a:t> a new </a:t>
+            </a:r>
+            <a:r>
+              <a:rPr lang="it-IT" dirty="0" err="1"/>
+              <a:t>queue</a:t>
+            </a:r>
+            <a:r>
+              <a:rPr lang="it-IT" dirty="0"/>
+              <a:t> with the name </a:t>
+            </a:r>
+            <a:r>
+              <a:rPr lang="it-IT" dirty="0" err="1"/>
+              <a:t>specified</a:t>
+            </a:r>
+            <a:r>
+              <a:rPr lang="it-IT" dirty="0"/>
+              <a:t> </a:t>
+            </a:r>
+            <a:r>
+              <a:rPr lang="it-IT" dirty="0" err="1"/>
+              <a:t>as</a:t>
+            </a:r>
+            <a:r>
+              <a:rPr lang="it-IT" dirty="0"/>
+              <a:t> </a:t>
+            </a:r>
+            <a:r>
+              <a:rPr lang="it-IT" dirty="0" err="1"/>
+              <a:t>parameter</a:t>
+            </a:r>
+            <a:r>
+              <a:rPr lang="it-IT" dirty="0"/>
+              <a:t> </a:t>
+            </a:r>
+            <a:r>
+              <a:rPr lang="it-IT" dirty="0" err="1">
+                <a:latin typeface="Cambria Math" panose="02040503050406030204" pitchFamily="18" charset="0"/>
+                <a:ea typeface="Cambria Math" panose="02040503050406030204" pitchFamily="18" charset="0"/>
+              </a:rPr>
+              <a:t>queue_name</a:t>
+            </a:r>
+            <a:r>
+              <a:rPr lang="it-IT" dirty="0"/>
+              <a:t>. In case the </a:t>
+            </a:r>
+            <a:r>
+              <a:rPr lang="it-IT" dirty="0" err="1"/>
+              <a:t>queue</a:t>
+            </a:r>
+            <a:r>
+              <a:rPr lang="it-IT" dirty="0"/>
+              <a:t> </a:t>
+            </a:r>
+            <a:r>
+              <a:rPr lang="it-IT" dirty="0" err="1"/>
+              <a:t>is</a:t>
+            </a:r>
+            <a:r>
+              <a:rPr lang="it-IT" dirty="0"/>
+              <a:t> </a:t>
+            </a:r>
+            <a:r>
+              <a:rPr lang="it-IT" dirty="0" err="1"/>
+              <a:t>already</a:t>
+            </a:r>
+            <a:r>
+              <a:rPr lang="it-IT" dirty="0"/>
+              <a:t> </a:t>
+            </a:r>
+            <a:r>
+              <a:rPr lang="it-IT" dirty="0" err="1"/>
+              <a:t>present</a:t>
+            </a:r>
+            <a:r>
+              <a:rPr lang="it-IT" dirty="0"/>
+              <a:t>, a warning </a:t>
+            </a:r>
+            <a:r>
+              <a:rPr lang="it-IT" dirty="0" err="1"/>
+              <a:t>is</a:t>
+            </a:r>
+            <a:r>
+              <a:rPr lang="it-IT" dirty="0"/>
+              <a:t> </a:t>
+            </a:r>
+            <a:r>
+              <a:rPr lang="it-IT" dirty="0" err="1"/>
+              <a:t>returned</a:t>
+            </a:r>
+            <a:r>
+              <a:rPr lang="it-IT" dirty="0"/>
+              <a:t> </a:t>
+            </a:r>
+            <a:r>
+              <a:rPr lang="it-IT" dirty="0" err="1"/>
+              <a:t>as</a:t>
+            </a:r>
+            <a:r>
+              <a:rPr lang="it-IT" dirty="0"/>
+              <a:t> </a:t>
+            </a:r>
+            <a:r>
+              <a:rPr lang="it-IT" dirty="0" err="1"/>
+              <a:t>response</a:t>
+            </a:r>
+            <a:r>
+              <a:rPr lang="it-IT" dirty="0"/>
+              <a:t>.</a:t>
+            </a:r>
+          </a:p>
+          <a:p>
+            <a:r>
+              <a:rPr lang="it-IT" dirty="0" err="1">
+                <a:latin typeface="Cambria Math" panose="02040503050406030204" pitchFamily="18" charset="0"/>
+                <a:ea typeface="Cambria Math" panose="02040503050406030204" pitchFamily="18" charset="0"/>
+              </a:rPr>
+              <a:t>append</a:t>
+            </a:r>
+            <a:r>
+              <a:rPr lang="it-IT" dirty="0">
+                <a:latin typeface="Cambria Math" panose="02040503050406030204" pitchFamily="18" charset="0"/>
+                <a:ea typeface="Cambria Math" panose="02040503050406030204" pitchFamily="18" charset="0"/>
+              </a:rPr>
+              <a:t> &lt;</a:t>
+            </a:r>
+            <a:r>
+              <a:rPr lang="it-IT" dirty="0" err="1">
+                <a:latin typeface="Cambria Math" panose="02040503050406030204" pitchFamily="18" charset="0"/>
+                <a:ea typeface="Cambria Math" panose="02040503050406030204" pitchFamily="18" charset="0"/>
+              </a:rPr>
+              <a:t>queue_name</a:t>
+            </a:r>
+            <a:r>
+              <a:rPr lang="it-IT" dirty="0">
+                <a:latin typeface="Cambria Math" panose="02040503050406030204" pitchFamily="18" charset="0"/>
+                <a:ea typeface="Cambria Math" panose="02040503050406030204" pitchFamily="18" charset="0"/>
+              </a:rPr>
+              <a:t>&gt; &lt;int_1&gt; &lt;int_2&gt; … &lt;</a:t>
+            </a:r>
+            <a:r>
+              <a:rPr lang="it-IT" dirty="0" err="1">
+                <a:latin typeface="Cambria Math" panose="02040503050406030204" pitchFamily="18" charset="0"/>
+                <a:ea typeface="Cambria Math" panose="02040503050406030204" pitchFamily="18" charset="0"/>
+              </a:rPr>
+              <a:t>int_n</a:t>
+            </a:r>
+            <a:r>
+              <a:rPr lang="it-IT" dirty="0">
+                <a:latin typeface="Cambria Math" panose="02040503050406030204" pitchFamily="18" charset="0"/>
+                <a:ea typeface="Cambria Math" panose="02040503050406030204" pitchFamily="18" charset="0"/>
+              </a:rPr>
+              <a:t>&gt;</a:t>
+            </a:r>
+          </a:p>
+          <a:p>
+            <a:pPr lvl="1"/>
+            <a:r>
+              <a:rPr lang="it-IT" dirty="0" err="1"/>
+              <a:t>Append</a:t>
+            </a:r>
+            <a:r>
+              <a:rPr lang="it-IT" dirty="0"/>
+              <a:t> to the </a:t>
+            </a:r>
+            <a:r>
+              <a:rPr lang="it-IT" dirty="0" err="1"/>
+              <a:t>queue</a:t>
+            </a:r>
+            <a:r>
+              <a:rPr lang="it-IT" dirty="0"/>
+              <a:t> </a:t>
+            </a:r>
+            <a:r>
+              <a:rPr lang="it-IT" dirty="0" err="1"/>
+              <a:t>specified</a:t>
+            </a:r>
+            <a:r>
+              <a:rPr lang="it-IT" dirty="0"/>
+              <a:t> </a:t>
+            </a:r>
+            <a:r>
+              <a:rPr lang="it-IT" dirty="0" err="1"/>
+              <a:t>as</a:t>
+            </a:r>
+            <a:r>
+              <a:rPr lang="it-IT" dirty="0"/>
+              <a:t> </a:t>
+            </a:r>
+            <a:r>
+              <a:rPr lang="it-IT" dirty="0" err="1"/>
+              <a:t>parameter</a:t>
+            </a:r>
+            <a:r>
+              <a:rPr lang="it-IT" dirty="0"/>
+              <a:t> </a:t>
+            </a:r>
+            <a:r>
+              <a:rPr lang="it-IT" dirty="0" err="1">
+                <a:latin typeface="Cambria Math" panose="02040503050406030204" pitchFamily="18" charset="0"/>
+                <a:ea typeface="Cambria Math" panose="02040503050406030204" pitchFamily="18" charset="0"/>
+              </a:rPr>
+              <a:t>queue_name</a:t>
+            </a:r>
+            <a:r>
+              <a:rPr lang="it-IT" dirty="0">
+                <a:latin typeface="Cambria Math" panose="02040503050406030204" pitchFamily="18" charset="0"/>
+                <a:ea typeface="Cambria Math" panose="02040503050406030204" pitchFamily="18" charset="0"/>
+              </a:rPr>
+              <a:t> </a:t>
+            </a:r>
+            <a:r>
+              <a:rPr lang="it-IT" dirty="0"/>
+              <a:t>the </a:t>
+            </a:r>
+            <a:r>
+              <a:rPr lang="it-IT" dirty="0" err="1"/>
+              <a:t>integer</a:t>
+            </a:r>
+            <a:r>
+              <a:rPr lang="it-IT" dirty="0"/>
+              <a:t> </a:t>
+            </a:r>
+            <a:r>
+              <a:rPr lang="it-IT" dirty="0" err="1"/>
+              <a:t>values</a:t>
+            </a:r>
+            <a:r>
+              <a:rPr lang="it-IT" dirty="0"/>
+              <a:t> </a:t>
+            </a:r>
+            <a:r>
+              <a:rPr lang="it-IT" dirty="0" err="1"/>
+              <a:t>specified</a:t>
+            </a:r>
+            <a:r>
+              <a:rPr lang="it-IT" dirty="0"/>
+              <a:t> </a:t>
+            </a:r>
+            <a:r>
+              <a:rPr lang="it-IT" dirty="0" err="1"/>
+              <a:t>afterwards</a:t>
+            </a:r>
+            <a:r>
+              <a:rPr lang="it-IT" dirty="0"/>
+              <a:t>, </a:t>
+            </a:r>
+            <a:r>
+              <a:rPr lang="it-IT" dirty="0" err="1"/>
+              <a:t>separated</a:t>
+            </a:r>
+            <a:r>
+              <a:rPr lang="it-IT" dirty="0"/>
+              <a:t> by a </a:t>
+            </a:r>
+            <a:r>
+              <a:rPr lang="it-IT" dirty="0" err="1"/>
+              <a:t>space</a:t>
+            </a:r>
+            <a:r>
+              <a:rPr lang="it-IT" dirty="0"/>
+              <a:t>. </a:t>
+            </a:r>
+          </a:p>
+          <a:p>
+            <a:pPr lvl="1"/>
+            <a:r>
+              <a:rPr lang="it-IT" dirty="0"/>
+              <a:t>A warning </a:t>
+            </a:r>
+            <a:r>
+              <a:rPr lang="it-IT" dirty="0" err="1"/>
+              <a:t>is</a:t>
+            </a:r>
+            <a:r>
+              <a:rPr lang="it-IT" dirty="0"/>
+              <a:t> </a:t>
+            </a:r>
+            <a:r>
+              <a:rPr lang="it-IT" dirty="0" err="1"/>
+              <a:t>returned</a:t>
+            </a:r>
+            <a:r>
+              <a:rPr lang="it-IT" dirty="0"/>
+              <a:t> in case the </a:t>
+            </a:r>
+            <a:r>
+              <a:rPr lang="it-IT" dirty="0" err="1"/>
+              <a:t>queue</a:t>
+            </a:r>
+            <a:r>
+              <a:rPr lang="it-IT" dirty="0"/>
+              <a:t> </a:t>
+            </a:r>
+            <a:r>
+              <a:rPr lang="it-IT" dirty="0" err="1"/>
+              <a:t>is</a:t>
+            </a:r>
+            <a:r>
+              <a:rPr lang="it-IT" dirty="0"/>
+              <a:t> </a:t>
+            </a:r>
+            <a:r>
+              <a:rPr lang="it-IT" dirty="0" err="1"/>
+              <a:t>unknown</a:t>
+            </a:r>
+            <a:r>
+              <a:rPr lang="it-IT" dirty="0"/>
+              <a:t>.</a:t>
+            </a:r>
+          </a:p>
+          <a:p>
+            <a:r>
+              <a:rPr lang="it-IT" dirty="0" err="1">
+                <a:latin typeface="Cambria Math" panose="02040503050406030204" pitchFamily="18" charset="0"/>
+                <a:ea typeface="Cambria Math" panose="02040503050406030204" pitchFamily="18" charset="0"/>
+              </a:rPr>
+              <a:t>read</a:t>
+            </a:r>
+            <a:r>
+              <a:rPr lang="it-IT" dirty="0">
+                <a:latin typeface="Cambria Math" panose="02040503050406030204" pitchFamily="18" charset="0"/>
+                <a:ea typeface="Cambria Math" panose="02040503050406030204" pitchFamily="18" charset="0"/>
+              </a:rPr>
+              <a:t> &lt;</a:t>
+            </a:r>
+            <a:r>
+              <a:rPr lang="it-IT" dirty="0" err="1">
+                <a:latin typeface="Cambria Math" panose="02040503050406030204" pitchFamily="18" charset="0"/>
+                <a:ea typeface="Cambria Math" panose="02040503050406030204" pitchFamily="18" charset="0"/>
+              </a:rPr>
+              <a:t>queue_name</a:t>
+            </a:r>
+            <a:r>
+              <a:rPr lang="it-IT" dirty="0">
+                <a:latin typeface="Cambria Math" panose="02040503050406030204" pitchFamily="18" charset="0"/>
+                <a:ea typeface="Cambria Math" panose="02040503050406030204" pitchFamily="18" charset="0"/>
+              </a:rPr>
+              <a:t>&gt;</a:t>
+            </a:r>
+          </a:p>
+          <a:p>
+            <a:pPr lvl="1"/>
+            <a:r>
+              <a:rPr lang="it-IT" dirty="0"/>
+              <a:t>Read </a:t>
+            </a:r>
+            <a:r>
+              <a:rPr lang="it-IT" dirty="0" err="1"/>
+              <a:t>all</a:t>
+            </a:r>
+            <a:r>
+              <a:rPr lang="it-IT" dirty="0"/>
+              <a:t> the </a:t>
+            </a:r>
+            <a:r>
+              <a:rPr lang="it-IT" dirty="0" err="1"/>
+              <a:t>values</a:t>
+            </a:r>
+            <a:r>
+              <a:rPr lang="it-IT" dirty="0"/>
+              <a:t> from the </a:t>
+            </a:r>
+            <a:r>
+              <a:rPr lang="it-IT" dirty="0" err="1"/>
+              <a:t>queue</a:t>
+            </a:r>
+            <a:r>
+              <a:rPr lang="it-IT" dirty="0"/>
+              <a:t> </a:t>
+            </a:r>
+            <a:r>
+              <a:rPr lang="it-IT" dirty="0" err="1"/>
+              <a:t>specified</a:t>
+            </a:r>
+            <a:r>
+              <a:rPr lang="it-IT" dirty="0"/>
+              <a:t> </a:t>
+            </a:r>
+            <a:r>
+              <a:rPr lang="it-IT" dirty="0" err="1"/>
+              <a:t>as</a:t>
+            </a:r>
+            <a:r>
+              <a:rPr lang="it-IT" dirty="0"/>
+              <a:t> </a:t>
+            </a:r>
+            <a:r>
+              <a:rPr lang="it-IT" dirty="0" err="1"/>
+              <a:t>parameter</a:t>
+            </a:r>
+            <a:r>
+              <a:rPr lang="it-IT" dirty="0"/>
+              <a:t> </a:t>
+            </a:r>
+            <a:r>
+              <a:rPr lang="it-IT" dirty="0" err="1">
+                <a:latin typeface="Cambria Math" panose="02040503050406030204" pitchFamily="18" charset="0"/>
+                <a:ea typeface="Cambria Math" panose="02040503050406030204" pitchFamily="18" charset="0"/>
+              </a:rPr>
+              <a:t>queue_name</a:t>
+            </a:r>
+            <a:r>
+              <a:rPr lang="it-IT" dirty="0">
+                <a:latin typeface="Cambria Math" panose="02040503050406030204" pitchFamily="18" charset="0"/>
+                <a:ea typeface="Cambria Math" panose="02040503050406030204" pitchFamily="18" charset="0"/>
+              </a:rPr>
+              <a:t> </a:t>
+            </a:r>
+            <a:r>
+              <a:rPr lang="it-IT" dirty="0" err="1"/>
+              <a:t>that</a:t>
+            </a:r>
+            <a:r>
+              <a:rPr lang="it-IT" dirty="0"/>
+              <a:t> are </a:t>
+            </a:r>
+            <a:r>
+              <a:rPr lang="it-IT" dirty="0" err="1"/>
+              <a:t>not</a:t>
+            </a:r>
+            <a:r>
+              <a:rPr lang="it-IT" dirty="0"/>
+              <a:t> </a:t>
+            </a:r>
+            <a:r>
+              <a:rPr lang="it-IT" dirty="0" err="1"/>
+              <a:t>yet</a:t>
+            </a:r>
+            <a:r>
+              <a:rPr lang="it-IT" dirty="0"/>
+              <a:t> </a:t>
+            </a:r>
+            <a:r>
+              <a:rPr lang="it-IT" dirty="0" err="1"/>
+              <a:t>read</a:t>
+            </a:r>
+            <a:r>
+              <a:rPr lang="it-IT" dirty="0"/>
+              <a:t> by the client.</a:t>
+            </a:r>
+          </a:p>
+          <a:p>
+            <a:pPr lvl="1"/>
+            <a:r>
+              <a:rPr lang="it-IT" dirty="0"/>
+              <a:t>A warning </a:t>
+            </a:r>
+            <a:r>
+              <a:rPr lang="it-IT" dirty="0" err="1"/>
+              <a:t>is</a:t>
+            </a:r>
+            <a:r>
+              <a:rPr lang="it-IT" dirty="0"/>
+              <a:t> </a:t>
+            </a:r>
+            <a:r>
+              <a:rPr lang="it-IT" dirty="0" err="1"/>
+              <a:t>returned</a:t>
+            </a:r>
+            <a:r>
+              <a:rPr lang="it-IT" dirty="0"/>
+              <a:t> in case the </a:t>
+            </a:r>
+            <a:r>
+              <a:rPr lang="it-IT" dirty="0" err="1"/>
+              <a:t>queue</a:t>
+            </a:r>
+            <a:r>
+              <a:rPr lang="it-IT" dirty="0"/>
+              <a:t> </a:t>
+            </a:r>
+            <a:r>
+              <a:rPr lang="it-IT" dirty="0" err="1"/>
+              <a:t>is</a:t>
+            </a:r>
+            <a:r>
+              <a:rPr lang="it-IT" dirty="0"/>
+              <a:t> </a:t>
+            </a:r>
+            <a:r>
+              <a:rPr lang="it-IT" dirty="0" err="1"/>
+              <a:t>unknown</a:t>
+            </a:r>
+            <a:r>
+              <a:rPr lang="it-IT" dirty="0"/>
+              <a:t> or </a:t>
+            </a:r>
+            <a:r>
+              <a:rPr lang="it-IT" dirty="0" err="1"/>
+              <a:t>if</a:t>
+            </a:r>
+            <a:r>
+              <a:rPr lang="it-IT" dirty="0"/>
+              <a:t> no new </a:t>
+            </a:r>
+            <a:r>
+              <a:rPr lang="it-IT" dirty="0" err="1"/>
+              <a:t>elements</a:t>
+            </a:r>
+            <a:r>
+              <a:rPr lang="it-IT" dirty="0"/>
+              <a:t> from the </a:t>
+            </a:r>
+            <a:r>
+              <a:rPr lang="it-IT" dirty="0" err="1"/>
+              <a:t>queue</a:t>
+            </a:r>
+            <a:r>
+              <a:rPr lang="it-IT" dirty="0"/>
+              <a:t> </a:t>
+            </a:r>
+            <a:r>
+              <a:rPr lang="it-IT" dirty="0" err="1"/>
+              <a:t>need</a:t>
+            </a:r>
+            <a:r>
+              <a:rPr lang="it-IT" dirty="0"/>
+              <a:t> to be </a:t>
+            </a:r>
+            <a:r>
+              <a:rPr lang="it-IT" dirty="0" err="1"/>
+              <a:t>read</a:t>
+            </a:r>
+            <a:r>
+              <a:rPr lang="it-IT" dirty="0"/>
+              <a:t>.</a:t>
+            </a:r>
           </a:p>
         </p:txBody>
       </p:sp>
     </p:spTree>
     <p:extLst>
       <p:ext uri="{BB962C8B-B14F-4D97-AF65-F5344CB8AC3E}">
-        <p14:creationId xmlns:p14="http://schemas.microsoft.com/office/powerpoint/2010/main" val="3690644163"/>
+        <p14:creationId xmlns:p14="http://schemas.microsoft.com/office/powerpoint/2010/main" val="2982348974"/>
       </p:ext>
     </p:extLst>
   </p:cSld>

</xml_diff>

<commit_message>
[DELIVERABLES] Added raft's slides to the presentation.
</commit_message>
<xml_diff>
--- a/ds-queuing-system/deliverables/slides/Presentazione Progetto.pptx
+++ b/ds-queuing-system/deliverables/slides/Presentazione Progetto.pptx
@@ -124,147 +124,12 @@
 <file path=ppt/revisionInfo.xml><?xml version="1.0" encoding="utf-8"?>
 <p1510:revInfo xmlns:a="http://schemas.openxmlformats.org/drawingml/2006/main" xmlns:r="http://schemas.openxmlformats.org/officeDocument/2006/relationships" xmlns:p1510="http://schemas.microsoft.com/office/powerpoint/2015/10/main">
   <p1510:revLst>
+    <p1510:client id="{233B9BCE-9227-AE89-9943-03348847C4D3}" v="100" dt="2024-09-02T13:22:40.423"/>
+    <p1510:client id="{91091765-1E62-AE05-BB44-2FD4DD8A80B8}" v="192" dt="2024-09-02T13:57:43.586"/>
     <p1510:client id="{9E00D13F-E25D-493A-BE7F-9E3BC15CB715}" v="4" dt="2024-09-01T18:16:48.519"/>
     <p1510:client id="{DC2CF1EE-756C-423F-B55B-7B3AE2B7E610}" v="1" dt="2024-09-02T07:48:12.260"/>
   </p1510:revLst>
 </p1510:revInfo>
-</file>
-
-<file path=ppt/changesInfos/changesInfo1.xml><?xml version="1.0" encoding="utf-8"?>
-<pc:chgInfo xmlns:a="http://schemas.openxmlformats.org/drawingml/2006/main" xmlns:r="http://schemas.openxmlformats.org/officeDocument/2006/relationships" xmlns:ac="http://schemas.microsoft.com/office/drawing/2013/main/command" xmlns:pc="http://schemas.microsoft.com/office/powerpoint/2013/main/command">
-  <pc:docChgLst>
-    <pc:chgData name="Matteo Figini" userId="b11f85f5-4439-44ce-8347-b655c4eb67c2" providerId="ADAL" clId="{9E00D13F-E25D-493A-BE7F-9E3BC15CB715}"/>
-    <pc:docChg chg="undo custSel addSld modSld">
-      <pc:chgData name="Matteo Figini" userId="b11f85f5-4439-44ce-8347-b655c4eb67c2" providerId="ADAL" clId="{9E00D13F-E25D-493A-BE7F-9E3BC15CB715}" dt="2024-09-01T18:17:27.438" v="263" actId="20577"/>
-      <pc:docMkLst>
-        <pc:docMk/>
-      </pc:docMkLst>
-      <pc:sldChg chg="modSp mod">
-        <pc:chgData name="Matteo Figini" userId="b11f85f5-4439-44ce-8347-b655c4eb67c2" providerId="ADAL" clId="{9E00D13F-E25D-493A-BE7F-9E3BC15CB715}" dt="2024-09-01T18:17:27.438" v="263" actId="20577"/>
-        <pc:sldMkLst>
-          <pc:docMk/>
-          <pc:sldMk cId="2532555055" sldId="256"/>
-        </pc:sldMkLst>
-        <pc:spChg chg="mod">
-          <ac:chgData name="Matteo Figini" userId="b11f85f5-4439-44ce-8347-b655c4eb67c2" providerId="ADAL" clId="{9E00D13F-E25D-493A-BE7F-9E3BC15CB715}" dt="2024-09-01T18:17:27.438" v="263" actId="20577"/>
-          <ac:spMkLst>
-            <pc:docMk/>
-            <pc:sldMk cId="2532555055" sldId="256"/>
-            <ac:spMk id="2" creationId="{6696C652-ADA6-7391-22C9-F72C0F85D8C7}"/>
-          </ac:spMkLst>
-        </pc:spChg>
-      </pc:sldChg>
-      <pc:sldChg chg="modSp mod">
-        <pc:chgData name="Matteo Figini" userId="b11f85f5-4439-44ce-8347-b655c4eb67c2" providerId="ADAL" clId="{9E00D13F-E25D-493A-BE7F-9E3BC15CB715}" dt="2024-09-01T18:11:54.147" v="141" actId="20577"/>
-        <pc:sldMkLst>
-          <pc:docMk/>
-          <pc:sldMk cId="4156629879" sldId="259"/>
-        </pc:sldMkLst>
-        <pc:spChg chg="mod">
-          <ac:chgData name="Matteo Figini" userId="b11f85f5-4439-44ce-8347-b655c4eb67c2" providerId="ADAL" clId="{9E00D13F-E25D-493A-BE7F-9E3BC15CB715}" dt="2024-09-01T18:11:54.147" v="141" actId="20577"/>
-          <ac:spMkLst>
-            <pc:docMk/>
-            <pc:sldMk cId="4156629879" sldId="259"/>
-            <ac:spMk id="3" creationId="{BE839F18-6640-632C-4C99-22B2A4BEA663}"/>
-          </ac:spMkLst>
-        </pc:spChg>
-      </pc:sldChg>
-      <pc:sldChg chg="modSp new mod">
-        <pc:chgData name="Matteo Figini" userId="b11f85f5-4439-44ce-8347-b655c4eb67c2" providerId="ADAL" clId="{9E00D13F-E25D-493A-BE7F-9E3BC15CB715}" dt="2024-09-01T18:17:01.636" v="255" actId="114"/>
-        <pc:sldMkLst>
-          <pc:docMk/>
-          <pc:sldMk cId="3690644163" sldId="264"/>
-        </pc:sldMkLst>
-        <pc:spChg chg="mod">
-          <ac:chgData name="Matteo Figini" userId="b11f85f5-4439-44ce-8347-b655c4eb67c2" providerId="ADAL" clId="{9E00D13F-E25D-493A-BE7F-9E3BC15CB715}" dt="2024-09-01T18:12:54.789" v="152" actId="20577"/>
-          <ac:spMkLst>
-            <pc:docMk/>
-            <pc:sldMk cId="3690644163" sldId="264"/>
-            <ac:spMk id="2" creationId="{55044361-9314-E206-27F5-289DA3FA9B64}"/>
-          </ac:spMkLst>
-        </pc:spChg>
-        <pc:spChg chg="mod">
-          <ac:chgData name="Matteo Figini" userId="b11f85f5-4439-44ce-8347-b655c4eb67c2" providerId="ADAL" clId="{9E00D13F-E25D-493A-BE7F-9E3BC15CB715}" dt="2024-09-01T18:17:01.636" v="255" actId="114"/>
-          <ac:spMkLst>
-            <pc:docMk/>
-            <pc:sldMk cId="3690644163" sldId="264"/>
-            <ac:spMk id="3" creationId="{CB2A3DC9-E5DA-5EC0-BAD1-763225B59A5A}"/>
-          </ac:spMkLst>
-        </pc:spChg>
-      </pc:sldChg>
-    </pc:docChg>
-  </pc:docChgLst>
-  <pc:docChgLst>
-    <pc:chgData name="Matteo Figini" userId="b11f85f5-4439-44ce-8347-b655c4eb67c2" providerId="ADAL" clId="{DC2CF1EE-756C-423F-B55B-7B3AE2B7E610}"/>
-    <pc:docChg chg="custSel addSld modSld">
-      <pc:chgData name="Matteo Figini" userId="b11f85f5-4439-44ce-8347-b655c4eb67c2" providerId="ADAL" clId="{DC2CF1EE-756C-423F-B55B-7B3AE2B7E610}" dt="2024-09-02T07:53:30.381" v="499" actId="20577"/>
-      <pc:docMkLst>
-        <pc:docMk/>
-      </pc:docMkLst>
-      <pc:sldChg chg="modSp mod">
-        <pc:chgData name="Matteo Figini" userId="b11f85f5-4439-44ce-8347-b655c4eb67c2" providerId="ADAL" clId="{DC2CF1EE-756C-423F-B55B-7B3AE2B7E610}" dt="2024-09-02T07:51:48.627" v="330" actId="20577"/>
-        <pc:sldMkLst>
-          <pc:docMk/>
-          <pc:sldMk cId="4156629879" sldId="259"/>
-        </pc:sldMkLst>
-        <pc:spChg chg="mod">
-          <ac:chgData name="Matteo Figini" userId="b11f85f5-4439-44ce-8347-b655c4eb67c2" providerId="ADAL" clId="{DC2CF1EE-756C-423F-B55B-7B3AE2B7E610}" dt="2024-09-02T07:51:48.627" v="330" actId="20577"/>
-          <ac:spMkLst>
-            <pc:docMk/>
-            <pc:sldMk cId="4156629879" sldId="259"/>
-            <ac:spMk id="3" creationId="{BE839F18-6640-632C-4C99-22B2A4BEA663}"/>
-          </ac:spMkLst>
-        </pc:spChg>
-      </pc:sldChg>
-      <pc:sldChg chg="addSp delSp modSp mod">
-        <pc:chgData name="Matteo Figini" userId="b11f85f5-4439-44ce-8347-b655c4eb67c2" providerId="ADAL" clId="{DC2CF1EE-756C-423F-B55B-7B3AE2B7E610}" dt="2024-09-02T07:48:16.817" v="5" actId="1076"/>
-        <pc:sldMkLst>
-          <pc:docMk/>
-          <pc:sldMk cId="4172879469" sldId="263"/>
-        </pc:sldMkLst>
-        <pc:spChg chg="del mod">
-          <ac:chgData name="Matteo Figini" userId="b11f85f5-4439-44ce-8347-b655c4eb67c2" providerId="ADAL" clId="{DC2CF1EE-756C-423F-B55B-7B3AE2B7E610}" dt="2024-09-02T07:48:12.260" v="1" actId="931"/>
-          <ac:spMkLst>
-            <pc:docMk/>
-            <pc:sldMk cId="4172879469" sldId="263"/>
-            <ac:spMk id="4" creationId="{5DF0977D-C95B-B580-720D-7DF932E314AD}"/>
-          </ac:spMkLst>
-        </pc:spChg>
-        <pc:picChg chg="add mod">
-          <ac:chgData name="Matteo Figini" userId="b11f85f5-4439-44ce-8347-b655c4eb67c2" providerId="ADAL" clId="{DC2CF1EE-756C-423F-B55B-7B3AE2B7E610}" dt="2024-09-02T07:48:16.817" v="5" actId="1076"/>
-          <ac:picMkLst>
-            <pc:docMk/>
-            <pc:sldMk cId="4172879469" sldId="263"/>
-            <ac:picMk id="6" creationId="{B3A92B76-4F6D-6D56-0085-86A406E797FB}"/>
-          </ac:picMkLst>
-        </pc:picChg>
-      </pc:sldChg>
-      <pc:sldChg chg="modSp new mod">
-        <pc:chgData name="Matteo Figini" userId="b11f85f5-4439-44ce-8347-b655c4eb67c2" providerId="ADAL" clId="{DC2CF1EE-756C-423F-B55B-7B3AE2B7E610}" dt="2024-09-02T07:53:30.381" v="499" actId="20577"/>
-        <pc:sldMkLst>
-          <pc:docMk/>
-          <pc:sldMk cId="1377587374" sldId="265"/>
-        </pc:sldMkLst>
-        <pc:spChg chg="mod">
-          <ac:chgData name="Matteo Figini" userId="b11f85f5-4439-44ce-8347-b655c4eb67c2" providerId="ADAL" clId="{DC2CF1EE-756C-423F-B55B-7B3AE2B7E610}" dt="2024-09-02T07:52:25.191" v="352" actId="20577"/>
-          <ac:spMkLst>
-            <pc:docMk/>
-            <pc:sldMk cId="1377587374" sldId="265"/>
-            <ac:spMk id="2" creationId="{A2C42C73-27A1-6C19-A4DF-E6C050EF7B05}"/>
-          </ac:spMkLst>
-        </pc:spChg>
-        <pc:spChg chg="mod">
-          <ac:chgData name="Matteo Figini" userId="b11f85f5-4439-44ce-8347-b655c4eb67c2" providerId="ADAL" clId="{DC2CF1EE-756C-423F-B55B-7B3AE2B7E610}" dt="2024-09-02T07:53:30.381" v="499" actId="20577"/>
-          <ac:spMkLst>
-            <pc:docMk/>
-            <pc:sldMk cId="1377587374" sldId="265"/>
-            <ac:spMk id="3" creationId="{7CAE885A-C0BC-F2A9-6F2B-12CF185EA1F3}"/>
-          </ac:spMkLst>
-        </pc:spChg>
-      </pc:sldChg>
-    </pc:docChg>
-  </pc:docChgLst>
-</pc:chgInfo>
 </file>
 
 <file path=ppt/slideLayouts/slideLayout1.xml><?xml version="1.0" encoding="utf-8"?>
@@ -5108,7 +4973,7 @@
         </p:nvSpPr>
         <p:spPr/>
         <p:txBody>
-          <a:bodyPr>
+          <a:bodyPr vert="horz" lIns="91440" tIns="45720" rIns="91440" bIns="45720" rtlCol="0" anchor="t">
             <a:normAutofit/>
           </a:bodyPr>
           <a:lstStyle/>
@@ -5151,7 +5016,7 @@
             </a:r>
             <a:r>
               <a:rPr lang="it-IT" dirty="0" err="1"/>
-              <a:t>having</a:t>
+              <a:t>maintaining</a:t>
             </a:r>
             <a:r>
               <a:rPr lang="it-IT" dirty="0"/>
@@ -5232,12 +5097,8 @@
           </a:p>
           <a:p>
             <a:r>
-              <a:rPr lang="it-IT" dirty="0"/>
-              <a:t>In </a:t>
-            </a:r>
-            <a:r>
-              <a:rPr lang="it-IT" dirty="0" err="1"/>
-              <a:t>detail</a:t>
+              <a:rPr lang="it-IT" dirty="0" err="1"/>
+              <a:t>Specifically</a:t>
             </a:r>
             <a:r>
               <a:rPr lang="it-IT" dirty="0"/>
@@ -5343,7 +5204,10 @@
               <a:rPr lang="it-IT" dirty="0" err="1"/>
               <a:t>traffic</a:t>
             </a:r>
-            <a:endParaRPr lang="it-IT" dirty="0"/>
+            <a:r>
+              <a:rPr lang="it-IT" dirty="0"/>
+              <a:t>.</a:t>
+            </a:r>
           </a:p>
           <a:p>
             <a:endParaRPr lang="it-IT" dirty="0"/>
@@ -5426,12 +5290,419 @@
         </p:nvSpPr>
         <p:spPr/>
         <p:txBody>
-          <a:bodyPr/>
-          <a:lstStyle/>
-          <a:p>
-            <a:r>
-              <a:rPr lang="it-IT"/>
-              <a:t>&lt;completare&gt; </a:t>
+          <a:bodyPr vert="horz" lIns="91440" tIns="45720" rIns="91440" bIns="45720" rtlCol="0" anchor="t">
+            <a:normAutofit/>
+          </a:bodyPr>
+          <a:lstStyle/>
+          <a:p>
+            <a:r>
+              <a:rPr lang="it-IT" dirty="0">
+                <a:ea typeface="+mn-lt"/>
+                <a:cs typeface="+mn-lt"/>
+              </a:rPr>
+              <a:t>Log </a:t>
+            </a:r>
+            <a:r>
+              <a:rPr lang="it-IT" dirty="0" err="1">
+                <a:ea typeface="+mn-lt"/>
+                <a:cs typeface="+mn-lt"/>
+              </a:rPr>
+              <a:t>structure</a:t>
+            </a:r>
+            <a:r>
+              <a:rPr lang="it-IT" dirty="0">
+                <a:ea typeface="+mn-lt"/>
+                <a:cs typeface="+mn-lt"/>
+              </a:rPr>
+              <a:t>: </a:t>
+            </a:r>
+            <a:r>
+              <a:rPr lang="it-IT" dirty="0" err="1">
+                <a:ea typeface="+mn-lt"/>
+                <a:cs typeface="+mn-lt"/>
+              </a:rPr>
+              <a:t>Individual</a:t>
+            </a:r>
+            <a:r>
+              <a:rPr lang="it-IT" dirty="0">
+                <a:ea typeface="+mn-lt"/>
+                <a:cs typeface="+mn-lt"/>
+              </a:rPr>
+              <a:t> </a:t>
+            </a:r>
+            <a:r>
+              <a:rPr lang="it-IT" dirty="0" err="1">
+                <a:ea typeface="+mn-lt"/>
+                <a:cs typeface="+mn-lt"/>
+              </a:rPr>
+              <a:t>operations</a:t>
+            </a:r>
+            <a:r>
+              <a:rPr lang="it-IT" dirty="0">
+                <a:ea typeface="+mn-lt"/>
+                <a:cs typeface="+mn-lt"/>
+              </a:rPr>
+              <a:t> (</a:t>
+            </a:r>
+            <a:r>
+              <a:rPr lang="it-IT" dirty="0" err="1">
+                <a:ea typeface="+mn-lt"/>
+                <a:cs typeface="+mn-lt"/>
+              </a:rPr>
+              <a:t>read</a:t>
+            </a:r>
+            <a:r>
+              <a:rPr lang="it-IT" dirty="0">
+                <a:ea typeface="+mn-lt"/>
+                <a:cs typeface="+mn-lt"/>
+              </a:rPr>
+              <a:t>/</a:t>
+            </a:r>
+            <a:r>
+              <a:rPr lang="it-IT" dirty="0" err="1">
+                <a:ea typeface="+mn-lt"/>
+                <a:cs typeface="+mn-lt"/>
+              </a:rPr>
+              <a:t>append</a:t>
+            </a:r>
+            <a:r>
+              <a:rPr lang="it-IT" dirty="0">
+                <a:ea typeface="+mn-lt"/>
+                <a:cs typeface="+mn-lt"/>
+              </a:rPr>
+              <a:t>/create) are </a:t>
+            </a:r>
+            <a:r>
+              <a:rPr lang="it-IT" dirty="0" err="1">
+                <a:ea typeface="+mn-lt"/>
+                <a:cs typeface="+mn-lt"/>
+              </a:rPr>
+              <a:t>stored</a:t>
+            </a:r>
+            <a:r>
+              <a:rPr lang="it-IT" dirty="0">
+                <a:ea typeface="+mn-lt"/>
+                <a:cs typeface="+mn-lt"/>
+              </a:rPr>
+              <a:t> in </a:t>
+            </a:r>
+            <a:r>
+              <a:rPr lang="it-IT" dirty="0" err="1">
+                <a:ea typeface="+mn-lt"/>
+                <a:cs typeface="+mn-lt"/>
+              </a:rPr>
+              <a:t>Raft's</a:t>
+            </a:r>
+            <a:r>
+              <a:rPr lang="it-IT" dirty="0">
+                <a:ea typeface="+mn-lt"/>
+                <a:cs typeface="+mn-lt"/>
+              </a:rPr>
+              <a:t> log. After a crash, </a:t>
+            </a:r>
+            <a:r>
+              <a:rPr lang="it-IT" dirty="0" err="1">
+                <a:ea typeface="+mn-lt"/>
+                <a:cs typeface="+mn-lt"/>
+              </a:rPr>
+              <a:t>nodes</a:t>
+            </a:r>
+            <a:r>
+              <a:rPr lang="it-IT" dirty="0">
+                <a:ea typeface="+mn-lt"/>
+                <a:cs typeface="+mn-lt"/>
+              </a:rPr>
+              <a:t> </a:t>
+            </a:r>
+            <a:r>
+              <a:rPr lang="it-IT" dirty="0" err="1">
+                <a:ea typeface="+mn-lt"/>
+                <a:cs typeface="+mn-lt"/>
+              </a:rPr>
+              <a:t>reconstruct</a:t>
+            </a:r>
+            <a:r>
+              <a:rPr lang="it-IT" dirty="0">
+                <a:ea typeface="+mn-lt"/>
+                <a:cs typeface="+mn-lt"/>
+              </a:rPr>
+              <a:t> the </a:t>
+            </a:r>
+            <a:r>
+              <a:rPr lang="it-IT" dirty="0" err="1">
+                <a:ea typeface="+mn-lt"/>
+                <a:cs typeface="+mn-lt"/>
+              </a:rPr>
+              <a:t>queues</a:t>
+            </a:r>
+            <a:r>
+              <a:rPr lang="it-IT" dirty="0">
+                <a:ea typeface="+mn-lt"/>
+                <a:cs typeface="+mn-lt"/>
+              </a:rPr>
+              <a:t> by </a:t>
+            </a:r>
+            <a:r>
+              <a:rPr lang="it-IT" dirty="0" err="1">
+                <a:ea typeface="+mn-lt"/>
+                <a:cs typeface="+mn-lt"/>
+              </a:rPr>
+              <a:t>replaying</a:t>
+            </a:r>
+            <a:r>
+              <a:rPr lang="it-IT" dirty="0">
+                <a:ea typeface="+mn-lt"/>
+                <a:cs typeface="+mn-lt"/>
+              </a:rPr>
+              <a:t> the </a:t>
+            </a:r>
+            <a:r>
+              <a:rPr lang="it-IT" dirty="0" err="1">
+                <a:ea typeface="+mn-lt"/>
+                <a:cs typeface="+mn-lt"/>
+              </a:rPr>
+              <a:t>operations</a:t>
+            </a:r>
+            <a:r>
+              <a:rPr lang="it-IT" dirty="0">
+                <a:ea typeface="+mn-lt"/>
+                <a:cs typeface="+mn-lt"/>
+              </a:rPr>
+              <a:t>.</a:t>
+            </a:r>
+            <a:endParaRPr lang="it-IT" dirty="0"/>
+          </a:p>
+          <a:p>
+            <a:r>
+              <a:rPr lang="it-IT" dirty="0">
+                <a:ea typeface="+mn-lt"/>
+                <a:cs typeface="+mn-lt"/>
+              </a:rPr>
+              <a:t>Client </a:t>
+            </a:r>
+            <a:r>
+              <a:rPr lang="it-IT" dirty="0" err="1">
+                <a:ea typeface="+mn-lt"/>
+                <a:cs typeface="+mn-lt"/>
+              </a:rPr>
+              <a:t>awareness</a:t>
+            </a:r>
+            <a:r>
+              <a:rPr lang="it-IT" dirty="0">
+                <a:ea typeface="+mn-lt"/>
+                <a:cs typeface="+mn-lt"/>
+              </a:rPr>
+              <a:t>: Clients can </a:t>
+            </a:r>
+            <a:r>
+              <a:rPr lang="it-IT" dirty="0" err="1">
+                <a:ea typeface="+mn-lt"/>
+                <a:cs typeface="+mn-lt"/>
+              </a:rPr>
+              <a:t>detect</a:t>
+            </a:r>
+            <a:r>
+              <a:rPr lang="it-IT" dirty="0">
+                <a:ea typeface="+mn-lt"/>
+                <a:cs typeface="+mn-lt"/>
+              </a:rPr>
+              <a:t> leader </a:t>
+            </a:r>
+            <a:r>
+              <a:rPr lang="it-IT" dirty="0" err="1">
+                <a:ea typeface="+mn-lt"/>
+                <a:cs typeface="+mn-lt"/>
+              </a:rPr>
+              <a:t>failures</a:t>
+            </a:r>
+            <a:r>
+              <a:rPr lang="it-IT" dirty="0">
+                <a:ea typeface="+mn-lt"/>
+                <a:cs typeface="+mn-lt"/>
+              </a:rPr>
+              <a:t> (via </a:t>
+            </a:r>
+            <a:r>
+              <a:rPr lang="it-IT" dirty="0" err="1">
+                <a:ea typeface="+mn-lt"/>
+                <a:cs typeface="+mn-lt"/>
+              </a:rPr>
+              <a:t>socket</a:t>
+            </a:r>
+            <a:r>
+              <a:rPr lang="it-IT" dirty="0">
+                <a:ea typeface="+mn-lt"/>
+                <a:cs typeface="+mn-lt"/>
+              </a:rPr>
+              <a:t> </a:t>
+            </a:r>
+            <a:r>
+              <a:rPr lang="it-IT" dirty="0" err="1">
+                <a:ea typeface="+mn-lt"/>
+                <a:cs typeface="+mn-lt"/>
+              </a:rPr>
+              <a:t>disconnection</a:t>
+            </a:r>
+            <a:r>
+              <a:rPr lang="it-IT" dirty="0">
+                <a:ea typeface="+mn-lt"/>
+                <a:cs typeface="+mn-lt"/>
+              </a:rPr>
+              <a:t> events). </a:t>
+            </a:r>
+            <a:r>
+              <a:rPr lang="it-IT" dirty="0" err="1">
+                <a:ea typeface="+mn-lt"/>
+                <a:cs typeface="+mn-lt"/>
+              </a:rPr>
+              <a:t>If</a:t>
+            </a:r>
+            <a:r>
+              <a:rPr lang="it-IT" dirty="0">
+                <a:ea typeface="+mn-lt"/>
+                <a:cs typeface="+mn-lt"/>
+              </a:rPr>
+              <a:t> </a:t>
+            </a:r>
+            <a:r>
+              <a:rPr lang="it-IT" dirty="0" err="1">
+                <a:ea typeface="+mn-lt"/>
+                <a:cs typeface="+mn-lt"/>
+              </a:rPr>
+              <a:t>that</a:t>
+            </a:r>
+            <a:r>
+              <a:rPr lang="it-IT" dirty="0">
+                <a:ea typeface="+mn-lt"/>
+                <a:cs typeface="+mn-lt"/>
+              </a:rPr>
+              <a:t> </a:t>
+            </a:r>
+            <a:r>
+              <a:rPr lang="it-IT" dirty="0" err="1">
+                <a:ea typeface="+mn-lt"/>
+                <a:cs typeface="+mn-lt"/>
+              </a:rPr>
+              <a:t>happens</a:t>
+            </a:r>
+            <a:r>
+              <a:rPr lang="it-IT" dirty="0">
+                <a:ea typeface="+mn-lt"/>
+                <a:cs typeface="+mn-lt"/>
+              </a:rPr>
+              <a:t>, </a:t>
+            </a:r>
+            <a:r>
+              <a:rPr lang="it-IT" dirty="0" err="1">
+                <a:ea typeface="+mn-lt"/>
+                <a:cs typeface="+mn-lt"/>
+              </a:rPr>
+              <a:t>they</a:t>
+            </a:r>
+            <a:r>
+              <a:rPr lang="it-IT" dirty="0">
+                <a:ea typeface="+mn-lt"/>
+                <a:cs typeface="+mn-lt"/>
+              </a:rPr>
+              <a:t> can </a:t>
+            </a:r>
+            <a:r>
+              <a:rPr lang="it-IT" dirty="0" err="1">
+                <a:ea typeface="+mn-lt"/>
+                <a:cs typeface="+mn-lt"/>
+              </a:rPr>
+              <a:t>request</a:t>
+            </a:r>
+            <a:r>
+              <a:rPr lang="it-IT" dirty="0">
+                <a:ea typeface="+mn-lt"/>
+                <a:cs typeface="+mn-lt"/>
+              </a:rPr>
+              <a:t> information </a:t>
+            </a:r>
+            <a:r>
+              <a:rPr lang="it-IT" dirty="0" err="1">
+                <a:ea typeface="+mn-lt"/>
+                <a:cs typeface="+mn-lt"/>
+              </a:rPr>
+              <a:t>about</a:t>
+            </a:r>
+            <a:r>
+              <a:rPr lang="it-IT" dirty="0">
+                <a:ea typeface="+mn-lt"/>
+                <a:cs typeface="+mn-lt"/>
+              </a:rPr>
+              <a:t> </a:t>
+            </a:r>
+            <a:r>
+              <a:rPr lang="it-IT" dirty="0" err="1">
+                <a:ea typeface="+mn-lt"/>
+                <a:cs typeface="+mn-lt"/>
+              </a:rPr>
+              <a:t>their</a:t>
+            </a:r>
+            <a:r>
+              <a:rPr lang="it-IT" dirty="0">
+                <a:ea typeface="+mn-lt"/>
+                <a:cs typeface="+mn-lt"/>
+              </a:rPr>
+              <a:t> </a:t>
+            </a:r>
+            <a:r>
+              <a:rPr lang="it-IT" dirty="0" err="1">
+                <a:ea typeface="+mn-lt"/>
+                <a:cs typeface="+mn-lt"/>
+              </a:rPr>
+              <a:t>pending</a:t>
+            </a:r>
+            <a:r>
+              <a:rPr lang="it-IT" dirty="0">
+                <a:ea typeface="+mn-lt"/>
+                <a:cs typeface="+mn-lt"/>
+              </a:rPr>
+              <a:t> </a:t>
+            </a:r>
+            <a:r>
+              <a:rPr lang="it-IT" dirty="0" err="1">
+                <a:ea typeface="+mn-lt"/>
+                <a:cs typeface="+mn-lt"/>
+              </a:rPr>
+              <a:t>operation</a:t>
+            </a:r>
+            <a:r>
+              <a:rPr lang="it-IT" dirty="0">
+                <a:ea typeface="+mn-lt"/>
+                <a:cs typeface="+mn-lt"/>
+              </a:rPr>
+              <a:t> (</a:t>
+            </a:r>
+            <a:r>
+              <a:rPr lang="it-IT" dirty="0" err="1">
+                <a:ea typeface="+mn-lt"/>
+                <a:cs typeface="+mn-lt"/>
+              </a:rPr>
+              <a:t>if</a:t>
+            </a:r>
+            <a:r>
+              <a:rPr lang="it-IT" dirty="0">
+                <a:ea typeface="+mn-lt"/>
+                <a:cs typeface="+mn-lt"/>
+              </a:rPr>
+              <a:t> </a:t>
+            </a:r>
+            <a:r>
+              <a:rPr lang="it-IT" dirty="0" err="1">
+                <a:ea typeface="+mn-lt"/>
+                <a:cs typeface="+mn-lt"/>
+              </a:rPr>
+              <a:t>any</a:t>
+            </a:r>
+            <a:r>
+              <a:rPr lang="it-IT" dirty="0">
+                <a:ea typeface="+mn-lt"/>
+                <a:cs typeface="+mn-lt"/>
+              </a:rPr>
+              <a:t>) from the new leader.</a:t>
             </a:r>
             <a:endParaRPr lang="it-IT" dirty="0"/>
           </a:p>

</xml_diff>